<commit_message>
Redesign SHIRAKU discussion paper: visual, simplified layout
- Restructured from 4 slides (6 items each) to 6 slides (4 items each)
- 4-item 2x2 grid per slide for cleaner visual layout
- Simplified text with visual flow indicators (STEP/①②③/Pattern A vs B)
- Added JSON schema example as code block in slide
- Split technical/business questions into separate slides

https://claude.ai/code/session_01TRkHFS2izteTGUG9tXtCZE
</commit_message>
<xml_diff>
--- a/shiraku_notta_api_discussion_presentation.pptx
+++ b/shiraku_notta_api_discussion_presentation.pptx
@@ -10,6 +10,7 @@
     <p:sldId id="258" r:id="rId9"/>
     <p:sldId id="259" r:id="rId10"/>
     <p:sldId id="260" r:id="rId11"/>
+    <p:sldId id="261" r:id="rId12"/>
   </p:sldIdLst>
   <p:sldSz cx="12188952" cy="6858000" type="screen4x3"/>
   <p:notesSz cx="6858000" cy="9144000"/>
@@ -3308,7 +3309,7 @@
                 </a:solidFill>
                 <a:latin typeface="Noto Sans"/>
               </a:rPr>
-              <a:t>SHIRAKUが実現したい連携の全体像</a:t>
+              <a:t>実現したい連携フロー</a:t>
             </a:r>
           </a:p>
         </p:txBody>
@@ -3384,7 +3385,7 @@
                 </a:solidFill>
                 <a:latin typeface="Noto Sans"/>
               </a:rPr>
-              <a:t>議事録動画 → Notta（AI文字起こし・Q&amp;A構造化）→ JSON送信 → Archi-RecordチェックリストへゼロタッチでQ&amp;Aが自動入力される世界</a:t>
+              <a:t>議事録動画 → Notta（AI処理）→ JSON自動送信 → Archi-Recordチェックリストに自動入力</a:t>
             </a:r>
           </a:p>
         </p:txBody>
@@ -3398,16 +3399,18 @@
         <p:spPr>
           <a:xfrm>
             <a:off x="548640" y="1897380"/>
-            <a:ext cx="5463540" cy="1437132"/>
+            <a:ext cx="5463540" cy="2237994"/>
           </a:xfrm>
           <a:prstGeom prst="rect">
             <a:avLst/>
           </a:prstGeom>
           <a:solidFill>
-            <a:srgbClr val="F5F5F5"/>
+            <a:srgbClr val="FFFFFF"/>
           </a:solidFill>
-          <a:ln>
-            <a:noFill/>
+          <a:ln w="9525">
+            <a:solidFill>
+              <a:srgbClr val="E0E0E0"/>
+            </a:solidFill>
           </a:ln>
         </p:spPr>
         <p:style>
@@ -3460,7 +3463,7 @@
                 </a:solidFill>
                 <a:latin typeface="Noto Sans"/>
               </a:rPr>
-              <a:t>①連携フロー4ステップ</a:t>
+              <a:t>STEP 1｜動画の取り込み</a:t>
             </a:r>
           </a:p>
         </p:txBody>
@@ -3474,7 +3477,7 @@
         <p:spPr>
           <a:xfrm>
             <a:off x="713232" y="2446020"/>
-            <a:ext cx="5134356" cy="723900"/>
+            <a:ext cx="5134356" cy="1524762"/>
           </a:xfrm>
           <a:prstGeom prst="rect">
             <a:avLst/>
@@ -3493,7 +3496,10 @@
                 </a:solidFill>
                 <a:latin typeface="Noto Sans"/>
               </a:rPr>
-              <a:t>【Step1】動画の撮影・アップロード → 【Step2】Nottaで議事録作成（音声解析・文字起こし・話者識別・質疑応答の構造化・タイムスタンプ付与）→ 【Step3】Archi-Recordへ自動送信（JSON形式）→ 【Step4】チェックリストに自動入力。現在の手動転記ゼロを実現する。</a:t>
+              <a:t>【Pattern A】Zoom MeetingにNotta Botを招待
+　→ Zoom参加者名を話者名に自動変換・高精度識別
+【Pattern B】録画済み MP4/MP3 をアップロード
+　→ 話者1・話者2として識別（後で名前を編集）</a:t>
             </a:r>
           </a:p>
         </p:txBody>
@@ -3507,16 +3513,18 @@
         <p:spPr>
           <a:xfrm>
             <a:off x="6176772" y="1897380"/>
-            <a:ext cx="5463540" cy="1437132"/>
+            <a:ext cx="5463540" cy="2237994"/>
           </a:xfrm>
           <a:prstGeom prst="rect">
             <a:avLst/>
           </a:prstGeom>
           <a:solidFill>
-            <a:srgbClr val="F5F5F5"/>
+            <a:srgbClr val="FFFFFF"/>
           </a:solidFill>
-          <a:ln>
-            <a:noFill/>
+          <a:ln w="9525">
+            <a:solidFill>
+              <a:srgbClr val="E0E0E0"/>
+            </a:solidFill>
           </a:ln>
         </p:spPr>
         <p:style>
@@ -3569,7 +3577,7 @@
                 </a:solidFill>
                 <a:latin typeface="Noto Sans"/>
               </a:rPr>
-              <a:t>②入力パターン A：Notta Bot使用</a:t>
+              <a:t>STEP 2｜Nottaで議事録を自動生成</a:t>
             </a:r>
           </a:p>
         </p:txBody>
@@ -3583,7 +3591,7 @@
         <p:spPr>
           <a:xfrm>
             <a:off x="6341364" y="2446020"/>
-            <a:ext cx="5134356" cy="723900"/>
+            <a:ext cx="5134356" cy="1524762"/>
           </a:xfrm>
           <a:prstGeom prst="rect">
             <a:avLst/>
@@ -3602,7 +3610,10 @@
                 </a:solidFill>
                 <a:latin typeface="Noto Sans"/>
               </a:rPr>
-              <a:t>Zoom Meetingにnotta botを招待。Zoom参加者名 → 話者名の自動マッピングにより高精度な話者識別を実現。SHIRAKUが最も期待するシナリオ。Notta BotがZoom SDKで参加し、リアルタイム文字起こし・Q&amp;A構造化を行う。</a:t>
+              <a:t>① 音声解析・文字起こし
+② 話者識別（スピーカー分離）
+③ 質疑応答をQ&amp;Aペアとして構造化
+④ タイムスタンプを各発言に付与</a:t>
             </a:r>
           </a:p>
         </p:txBody>
@@ -3615,17 +3626,19 @@
         </p:nvSpPr>
         <p:spPr>
           <a:xfrm>
-            <a:off x="548640" y="3499104"/>
-            <a:ext cx="5463540" cy="1437132"/>
+            <a:off x="548640" y="4299966"/>
+            <a:ext cx="5463540" cy="2237994"/>
           </a:xfrm>
           <a:prstGeom prst="rect">
             <a:avLst/>
           </a:prstGeom>
           <a:solidFill>
-            <a:srgbClr val="F5F5F5"/>
+            <a:srgbClr val="FFFFFF"/>
           </a:solidFill>
-          <a:ln>
-            <a:noFill/>
+          <a:ln w="9525">
+            <a:solidFill>
+              <a:srgbClr val="E0E0E0"/>
+            </a:solidFill>
           </a:ln>
         </p:spPr>
         <p:style>
@@ -3658,7 +3671,7 @@
         </p:nvSpPr>
         <p:spPr>
           <a:xfrm>
-            <a:off x="713232" y="3663696"/>
+            <a:off x="713232" y="4464558"/>
             <a:ext cx="5134356" cy="347472"/>
           </a:xfrm>
           <a:prstGeom prst="rect">
@@ -3678,7 +3691,7 @@
                 </a:solidFill>
                 <a:latin typeface="Noto Sans"/>
               </a:rPr>
-              <a:t>③入力パターン B：MP4/MP3アップロード</a:t>
+              <a:t>STEP 3｜JSON形式でArchi-Recordへ自動送信</a:t>
             </a:r>
           </a:p>
         </p:txBody>
@@ -3691,8 +3704,8 @@
         </p:nvSpPr>
         <p:spPr>
           <a:xfrm>
-            <a:off x="713232" y="4047744"/>
-            <a:ext cx="5134356" cy="723900"/>
+            <a:off x="713232" y="4848606"/>
+            <a:ext cx="5134356" cy="1524762"/>
           </a:xfrm>
           <a:prstGeom prst="rect">
             <a:avLst/>
@@ -3711,7 +3724,12 @@
                 </a:solidFill>
                 <a:latin typeface="Noto Sans"/>
               </a:rPr>
-              <a:t>録画済みの動画ファイルをNottaにアップロード。「話者1・話者2…」としての基本的な話者識別。ZoomのBot参加が難しい会議（対面・外部システム等）の補完手段として位置づけ。話者名の後付け編集が必要になるケースあり。</a:t>
+              <a:t>1レコード＝Q&amp;Aペア1組
+　• 質問内容 / 質問者
+　• 回答 / 回答者
+　• スクリーンショット（候補3-5枚）
+　• タイムスタンプ
+議事録確定 → Webhook POSTで自動配信</a:t>
             </a:r>
           </a:p>
         </p:txBody>
@@ -3724,17 +3742,19 @@
         </p:nvSpPr>
         <p:spPr>
           <a:xfrm>
-            <a:off x="6176772" y="3499104"/>
-            <a:ext cx="5463540" cy="1437132"/>
+            <a:off x="6176772" y="4299966"/>
+            <a:ext cx="5463540" cy="2237994"/>
           </a:xfrm>
           <a:prstGeom prst="rect">
             <a:avLst/>
           </a:prstGeom>
           <a:solidFill>
-            <a:srgbClr val="F5F5F5"/>
+            <a:srgbClr val="FFFFFF"/>
           </a:solidFill>
-          <a:ln>
-            <a:noFill/>
+          <a:ln w="9525">
+            <a:solidFill>
+              <a:srgbClr val="E0E0E0"/>
+            </a:solidFill>
           </a:ln>
         </p:spPr>
         <p:style>
@@ -3767,7 +3787,7 @@
         </p:nvSpPr>
         <p:spPr>
           <a:xfrm>
-            <a:off x="6341364" y="3663696"/>
+            <a:off x="6341364" y="4464558"/>
             <a:ext cx="5134356" cy="347472"/>
           </a:xfrm>
           <a:prstGeom prst="rect">
@@ -3787,7 +3807,7 @@
                 </a:solidFill>
                 <a:latin typeface="Noto Sans"/>
               </a:rPr>
-              <a:t>④Archi-Recordが欲しいJSONデータ</a:t>
+              <a:t>STEP 4｜チェックリストへ自動入力</a:t>
             </a:r>
           </a:p>
         </p:txBody>
@@ -3800,8 +3820,8 @@
         </p:nvSpPr>
         <p:spPr>
           <a:xfrm>
-            <a:off x="6341364" y="4047744"/>
-            <a:ext cx="5134356" cy="723900"/>
+            <a:off x="6341364" y="4848606"/>
+            <a:ext cx="5134356" cy="1524762"/>
           </a:xfrm>
           <a:prstGeom prst="rect">
             <a:avLst/>
@@ -3820,225 +3840,12 @@
                 </a:solidFill>
                 <a:latin typeface="Noto Sans"/>
               </a:rPr>
-              <a:t>1レコードの構成：【質問内容】【質問者】【回答】【回答者】【スクリーンショット（候補3-5枚）】＋【タイムスタンプ】。Archi-Record側のCheck ListにはAttach機能（画像添付）・質問者・内容・回答者フィールドが存在し、JSONの各フィールドと1対1で対応。</a:t>
-            </a:r>
-          </a:p>
-        </p:txBody>
-      </p:sp>
-      <p:sp>
-        <p:nvSpPr>
-          <p:cNvPr id="17" name="Rectangle 16"/>
-          <p:cNvSpPr/>
-          <p:nvPr/>
-        </p:nvSpPr>
-        <p:spPr>
-          <a:xfrm>
-            <a:off x="548640" y="5100828"/>
-            <a:ext cx="5463540" cy="1437132"/>
-          </a:xfrm>
-          <a:prstGeom prst="rect">
-            <a:avLst/>
-          </a:prstGeom>
-          <a:solidFill>
-            <a:srgbClr val="F5F5F5"/>
-          </a:solidFill>
-          <a:ln>
-            <a:noFill/>
-          </a:ln>
-        </p:spPr>
-        <p:style>
-          <a:lnRef idx="1">
-            <a:schemeClr val="accent1"/>
-          </a:lnRef>
-          <a:fillRef idx="3">
-            <a:schemeClr val="accent1"/>
-          </a:fillRef>
-          <a:effectRef idx="2">
-            <a:schemeClr val="accent1"/>
-          </a:effectRef>
-          <a:fontRef idx="minor">
-            <a:schemeClr val="lt1"/>
-          </a:fontRef>
-        </p:style>
-        <p:txBody>
-          <a:bodyPr rtlCol="0" anchor="ctr"/>
-          <a:lstStyle/>
-          <a:p>
-            <a:pPr algn="ctr"/>
-          </a:p>
-        </p:txBody>
-      </p:sp>
-      <p:sp>
-        <p:nvSpPr>
-          <p:cNvPr id="18" name="TextBox 17"/>
-          <p:cNvSpPr txBox="1"/>
-          <p:nvPr/>
-        </p:nvSpPr>
-        <p:spPr>
-          <a:xfrm>
-            <a:off x="713232" y="5265420"/>
-            <a:ext cx="5134356" cy="347472"/>
-          </a:xfrm>
-          <a:prstGeom prst="rect">
-            <a:avLst/>
-          </a:prstGeom>
-          <a:noFill/>
-        </p:spPr>
-        <p:txBody>
-          <a:bodyPr wrap="square"/>
-          <a:lstStyle/>
-          <a:p>
-            <a:pPr algn="l"/>
-            <a:r>
-              <a:rPr sz="1800" b="1">
-                <a:solidFill>
-                  <a:srgbClr val="2180FF"/>
-                </a:solidFill>
-                <a:latin typeface="Noto Sans"/>
-              </a:rPr>
-              <a:t>⑤NottaアプリのUI連携イメージ</a:t>
-            </a:r>
-          </a:p>
-        </p:txBody>
-      </p:sp>
-      <p:sp>
-        <p:nvSpPr>
-          <p:cNvPr id="19" name="TextBox 18"/>
-          <p:cNvSpPr txBox="1"/>
-          <p:nvPr/>
-        </p:nvSpPr>
-        <p:spPr>
-          <a:xfrm>
-            <a:off x="713232" y="5649468"/>
-            <a:ext cx="5134356" cy="723900"/>
-          </a:xfrm>
-          <a:prstGeom prst="rect">
-            <a:avLst/>
-          </a:prstGeom>
-          <a:noFill/>
-        </p:spPr>
-        <p:txBody>
-          <a:bodyPr wrap="square"/>
-          <a:lstStyle/>
-          <a:p>
-            <a:pPr algn="l"/>
-            <a:r>
-              <a:rPr sz="1200" b="0">
-                <a:solidFill>
-                  <a:srgbClr val="262626"/>
-                </a:solidFill>
-                <a:latin typeface="Noto Sans"/>
-              </a:rPr>
-              <a:t>「連携とアプリ」→「すべての連携サービス」にArchi-Recordを追加。Slack・Salesforce・HubSpot等と同等のUIで「連携する」ボタンから設定。オートメーション設定で「アクション：Archi-Recordに同期」「オプション：Archi-Recordのプロジェクトを選択」というUX設計を想定。</a:t>
-            </a:r>
-          </a:p>
-        </p:txBody>
-      </p:sp>
-      <p:sp>
-        <p:nvSpPr>
-          <p:cNvPr id="20" name="Rectangle 19"/>
-          <p:cNvSpPr/>
-          <p:nvPr/>
-        </p:nvSpPr>
-        <p:spPr>
-          <a:xfrm>
-            <a:off x="6176772" y="5100828"/>
-            <a:ext cx="5463540" cy="1437132"/>
-          </a:xfrm>
-          <a:prstGeom prst="rect">
-            <a:avLst/>
-          </a:prstGeom>
-          <a:solidFill>
-            <a:srgbClr val="F5F5F5"/>
-          </a:solidFill>
-          <a:ln>
-            <a:noFill/>
-          </a:ln>
-        </p:spPr>
-        <p:style>
-          <a:lnRef idx="1">
-            <a:schemeClr val="accent1"/>
-          </a:lnRef>
-          <a:fillRef idx="3">
-            <a:schemeClr val="accent1"/>
-          </a:fillRef>
-          <a:effectRef idx="2">
-            <a:schemeClr val="accent1"/>
-          </a:effectRef>
-          <a:fontRef idx="minor">
-            <a:schemeClr val="lt1"/>
-          </a:fontRef>
-        </p:style>
-        <p:txBody>
-          <a:bodyPr rtlCol="0" anchor="ctr"/>
-          <a:lstStyle/>
-          <a:p>
-            <a:pPr algn="ctr"/>
-          </a:p>
-        </p:txBody>
-      </p:sp>
-      <p:sp>
-        <p:nvSpPr>
-          <p:cNvPr id="21" name="TextBox 20"/>
-          <p:cNvSpPr txBox="1"/>
-          <p:nvPr/>
-        </p:nvSpPr>
-        <p:spPr>
-          <a:xfrm>
-            <a:off x="6341364" y="5265420"/>
-            <a:ext cx="5134356" cy="347472"/>
-          </a:xfrm>
-          <a:prstGeom prst="rect">
-            <a:avLst/>
-          </a:prstGeom>
-          <a:noFill/>
-        </p:spPr>
-        <p:txBody>
-          <a:bodyPr wrap="square"/>
-          <a:lstStyle/>
-          <a:p>
-            <a:pPr algn="l"/>
-            <a:r>
-              <a:rPr sz="1800" b="1">
-                <a:solidFill>
-                  <a:srgbClr val="2180FF"/>
-                </a:solidFill>
-                <a:latin typeface="Noto Sans"/>
-              </a:rPr>
-              <a:t>⑥スクリーンショットのコンセプト</a:t>
-            </a:r>
-          </a:p>
-        </p:txBody>
-      </p:sp>
-      <p:sp>
-        <p:nvSpPr>
-          <p:cNvPr id="22" name="TextBox 21"/>
-          <p:cNvSpPr txBox="1"/>
-          <p:nvPr/>
-        </p:nvSpPr>
-        <p:spPr>
-          <a:xfrm>
-            <a:off x="6341364" y="5649468"/>
-            <a:ext cx="5134356" cy="723900"/>
-          </a:xfrm>
-          <a:prstGeom prst="rect">
-            <a:avLst/>
-          </a:prstGeom>
-          <a:noFill/>
-        </p:spPr>
-        <p:txBody>
-          <a:bodyPr wrap="square"/>
-          <a:lstStyle/>
-          <a:p>
-            <a:pPr algn="l"/>
-            <a:r>
-              <a:rPr sz="1200" b="0">
-                <a:solidFill>
-                  <a:srgbClr val="262626"/>
-                </a:solidFill>
-                <a:latin typeface="Noto Sans"/>
-              </a:rPr>
-              <a:t>質問者・回答者が発話した区間の映像キャプチャ。基本1枚で十分（多くは不要）。取得案：質問者のタイムスタンプ起点から10秒に1回程度のざっくりキャプチャ。動画ファイル自体はNotta側に保存不要（ストレージ節約）。プライバシー配慮の法的確認が要件。</a:t>
+              <a:t>Archi-RecordのCheck Listに
+各Q&amp;Aペアが1行ずつ自動追加：
+　□ 質問内容 ／ 質問者
+　□ 回答内容 ／ 回答者
+　📷 スクリーンショット（添付）
+→ 手動転記ゼロ・ミス防止</a:t>
             </a:r>
           </a:p>
         </p:txBody>
@@ -4097,7 +3904,7 @@
                 </a:solidFill>
                 <a:latin typeface="Noto Sans"/>
               </a:rPr>
-              <a:t>NottaのAPI開発で考慮すべき事項</a:t>
+              <a:t>送受信するJSONデータの仕様</a:t>
             </a:r>
           </a:p>
         </p:txBody>
@@ -4173,7 +3980,7 @@
                 </a:solidFill>
                 <a:latin typeface="Noto Sans"/>
               </a:rPr>
-              <a:t>「連携サービス追加UI」「Q&amp;A構造化エンジン」「スクリーンショット取得」「OAuthフロー設計」の4領域がNotta側の主要開発テーマ</a:t>
+              <a:t>1レコード＝Q&amp;Aペア1組。5フィールド＋タイムスタンプで構成。スクリーンショットは基本1枚</a:t>
             </a:r>
           </a:p>
         </p:txBody>
@@ -4187,16 +3994,18 @@
         <p:spPr>
           <a:xfrm>
             <a:off x="548640" y="1897380"/>
-            <a:ext cx="5463540" cy="1437132"/>
+            <a:ext cx="5463540" cy="2237994"/>
           </a:xfrm>
           <a:prstGeom prst="rect">
             <a:avLst/>
           </a:prstGeom>
           <a:solidFill>
-            <a:srgbClr val="F5F5F5"/>
+            <a:srgbClr val="FFFFFF"/>
           </a:solidFill>
-          <a:ln>
-            <a:noFill/>
+          <a:ln w="9525">
+            <a:solidFill>
+              <a:srgbClr val="E0E0E0"/>
+            </a:solidFill>
           </a:ln>
         </p:spPr>
         <p:style>
@@ -4249,7 +4058,7 @@
                 </a:solidFill>
                 <a:latin typeface="Noto Sans"/>
               </a:rPr>
-              <a:t>①Notta連携サービスへのArchi-Record追加</a:t>
+              <a:t>JSONフィールド構成（1レコード）</a:t>
             </a:r>
           </a:p>
         </p:txBody>
@@ -4263,7 +4072,7 @@
         <p:spPr>
           <a:xfrm>
             <a:off x="713232" y="2446020"/>
-            <a:ext cx="5134356" cy="723900"/>
+            <a:ext cx="5134356" cy="1524762"/>
           </a:xfrm>
           <a:prstGeom prst="rect">
             <a:avLst/>
@@ -4282,7 +4091,14 @@
                 </a:solidFill>
                 <a:latin typeface="Noto Sans"/>
               </a:rPr>
-              <a:t>既存の「連携とアプリ」UIにArchi-Recordを追加するためのサービスカタログ登録・アイコン・説明文の整備が必要。Slack・Salesforce等と同様のパートナー連携フレームワークにArchi-Recordを組み込む。オートメーションエンジン側に「Archi-Recordへ送信」アクションを新規追加し、プロジェクトを選択できるUIコンポーネントを実装。</a:t>
+              <a:t>{
+  "question"     : "質問の内容テキスト",
+  "questioner"   : "質問者の名前",
+  "answer"       : "回答の内容テキスト",
+  "answerer"     : "回答者の名前",
+  "screenshots"  : ["url1", "url2", ...],
+  "timestamp"    : "00:12:34"
+}</a:t>
             </a:r>
           </a:p>
         </p:txBody>
@@ -4296,16 +4112,18 @@
         <p:spPr>
           <a:xfrm>
             <a:off x="6176772" y="1897380"/>
-            <a:ext cx="5463540" cy="1437132"/>
+            <a:ext cx="5463540" cy="2237994"/>
           </a:xfrm>
           <a:prstGeom prst="rect">
             <a:avLst/>
           </a:prstGeom>
           <a:solidFill>
-            <a:srgbClr val="F5F5F5"/>
+            <a:srgbClr val="FFFFFF"/>
           </a:solidFill>
-          <a:ln>
-            <a:noFill/>
+          <a:ln w="9525">
+            <a:solidFill>
+              <a:srgbClr val="E0E0E0"/>
+            </a:solidFill>
           </a:ln>
         </p:spPr>
         <p:style>
@@ -4358,7 +4176,7 @@
                 </a:solidFill>
                 <a:latin typeface="Noto Sans"/>
               </a:rPr>
-              <a:t>②OAuthフロー設計（Google SSO考慮）</a:t>
+              <a:t>スクリーンショットの取得方針</a:t>
             </a:r>
           </a:p>
         </p:txBody>
@@ -4372,7 +4190,7 @@
         <p:spPr>
           <a:xfrm>
             <a:off x="6341364" y="2446020"/>
-            <a:ext cx="5134356" cy="723900"/>
+            <a:ext cx="5134356" cy="1524762"/>
           </a:xfrm>
           <a:prstGeom prst="rect">
             <a:avLst/>
@@ -4391,7 +4209,12 @@
                 </a:solidFill>
                 <a:latin typeface="Noto Sans"/>
               </a:rPr>
-              <a:t>Archi-RecordはGoogle認証を採用しているため、Slack型OAuthとの差分設計が必要。候補アプローチ：（A）Notta側がArchi-RecordのOAuth 2.0クライアントになりAuthorization Code Flowで認証、（B）Google IDトークンをArchi-Recordのバックエンドに転送してセッション連携。Archi-Record側がNotta向けにOAuth Clientを発行できるかを確認必須。</a:t>
+              <a:t>【取得タイミング】
+　質問者の発話開始タイムスタンプ起点
+　→ 10秒ごとに1枚ずつキャプチャ
+【枚数】基本1枚でOK（3-5枚候補から選択）
+【動画ファイル】処理後は保存不要
+　→ ストレージ節約・プライバシー配慮</a:t>
             </a:r>
           </a:p>
         </p:txBody>
@@ -4404,17 +4227,19 @@
         </p:nvSpPr>
         <p:spPr>
           <a:xfrm>
-            <a:off x="548640" y="3499104"/>
-            <a:ext cx="5463540" cy="1437132"/>
+            <a:off x="548640" y="4299966"/>
+            <a:ext cx="5463540" cy="2237994"/>
           </a:xfrm>
           <a:prstGeom prst="rect">
             <a:avLst/>
           </a:prstGeom>
           <a:solidFill>
-            <a:srgbClr val="F5F5F5"/>
+            <a:srgbClr val="FFFFFF"/>
           </a:solidFill>
-          <a:ln>
-            <a:noFill/>
+          <a:ln w="9525">
+            <a:solidFill>
+              <a:srgbClr val="E0E0E0"/>
+            </a:solidFill>
           </a:ln>
         </p:spPr>
         <p:style>
@@ -4447,7 +4272,7 @@
         </p:nvSpPr>
         <p:spPr>
           <a:xfrm>
-            <a:off x="713232" y="3663696"/>
+            <a:off x="713232" y="4464558"/>
             <a:ext cx="5134356" cy="347472"/>
           </a:xfrm>
           <a:prstGeom prst="rect">
@@ -4467,7 +4292,7 @@
                 </a:solidFill>
                 <a:latin typeface="Noto Sans"/>
               </a:rPr>
-              <a:t>③Q&amp;A構造化ロジックの設計</a:t>
+              <a:t>Pattern A vs B　話者識別精度比較</a:t>
             </a:r>
           </a:p>
         </p:txBody>
@@ -4480,8 +4305,8 @@
         </p:nvSpPr>
         <p:spPr>
           <a:xfrm>
-            <a:off x="713232" y="4047744"/>
-            <a:ext cx="5134356" cy="723900"/>
+            <a:off x="713232" y="4848606"/>
+            <a:ext cx="5134356" cy="1524762"/>
           </a:xfrm>
           <a:prstGeom prst="rect">
             <a:avLst/>
@@ -4500,7 +4325,13 @@
                 </a:solidFill>
                 <a:latin typeface="Noto Sans"/>
               </a:rPr>
-              <a:t>発話ストリームから「質問」「回答」ペアを自動抽出するAIパイプラインを設計。アプローチ：（A）LLMによるターン意図分類（高精度・コスト高）、（B）疑問符・疑問助詞・スピーカー交替のルールベース（高速・低コスト）。建築業界特有の専門用語（工法名・図面番号等）への対応プロンプト設計も検討。ZoomのDisplay Name → Archi-Record内話者名のマッピング機構を実装。</a:t>
+              <a:t>【Pattern A】Notta Bot（Zoom参加）
+　◎ Zoom表示名 → 話者名を自動変換
+　◎ 高精度な話者識別
+　→ 推奨シナリオ
+【Pattern B】MP4/MP3 アップロード
+　△ 「話者1・話者2」で識別
+　→ 名前の後付け編集が必要</a:t>
             </a:r>
           </a:p>
         </p:txBody>
@@ -4513,17 +4344,19 @@
         </p:nvSpPr>
         <p:spPr>
           <a:xfrm>
-            <a:off x="6176772" y="3499104"/>
-            <a:ext cx="5463540" cy="1437132"/>
+            <a:off x="6176772" y="4299966"/>
+            <a:ext cx="5463540" cy="2237994"/>
           </a:xfrm>
           <a:prstGeom prst="rect">
             <a:avLst/>
           </a:prstGeom>
           <a:solidFill>
-            <a:srgbClr val="F5F5F5"/>
+            <a:srgbClr val="FFFFFF"/>
           </a:solidFill>
-          <a:ln>
-            <a:noFill/>
+          <a:ln w="9525">
+            <a:solidFill>
+              <a:srgbClr val="E0E0E0"/>
+            </a:solidFill>
           </a:ln>
         </p:spPr>
         <p:style>
@@ -4556,7 +4389,7 @@
         </p:nvSpPr>
         <p:spPr>
           <a:xfrm>
-            <a:off x="6341364" y="3663696"/>
+            <a:off x="6341364" y="4464558"/>
             <a:ext cx="5134356" cy="347472"/>
           </a:xfrm>
           <a:prstGeom prst="rect">
@@ -4576,7 +4409,7 @@
                 </a:solidFill>
                 <a:latin typeface="Noto Sans"/>
               </a:rPr>
-              <a:t>④スクリーンショット取得の技術課題</a:t>
+              <a:t>NottaのUIでの連携イメージ</a:t>
             </a:r>
           </a:p>
         </p:txBody>
@@ -4589,8 +4422,8 @@
         </p:nvSpPr>
         <p:spPr>
           <a:xfrm>
-            <a:off x="6341364" y="4047744"/>
-            <a:ext cx="5134356" cy="723900"/>
+            <a:off x="6341364" y="4848606"/>
+            <a:ext cx="5134356" cy="1524762"/>
           </a:xfrm>
           <a:prstGeom prst="rect">
             <a:avLst/>
@@ -4609,225 +4442,12 @@
                 </a:solidFill>
                 <a:latin typeface="Noto Sans"/>
               </a:rPr>
-              <a:t>映像ソース（Zoom録画API / MP4ファイル）から指定タイムスタンプのフレームを抽出する機能が必要。実装案：Zoom Cloud Recordingのダウンロード → ffmpegによるフレーム抽出 → Notta CDNにアップロードしURLを生成。動画ファイルをNottaに永続保存せず処理後に削除することでストレージコストを抑制。スクリーンショットに第三者の映像が映り込む場合の法的・プライバシー対応も要検討。</a:t>
-            </a:r>
-          </a:p>
-        </p:txBody>
-      </p:sp>
-      <p:sp>
-        <p:nvSpPr>
-          <p:cNvPr id="17" name="Rectangle 16"/>
-          <p:cNvSpPr/>
-          <p:nvPr/>
-        </p:nvSpPr>
-        <p:spPr>
-          <a:xfrm>
-            <a:off x="548640" y="5100828"/>
-            <a:ext cx="5463540" cy="1437132"/>
-          </a:xfrm>
-          <a:prstGeom prst="rect">
-            <a:avLst/>
-          </a:prstGeom>
-          <a:solidFill>
-            <a:srgbClr val="F5F5F5"/>
-          </a:solidFill>
-          <a:ln>
-            <a:noFill/>
-          </a:ln>
-        </p:spPr>
-        <p:style>
-          <a:lnRef idx="1">
-            <a:schemeClr val="accent1"/>
-          </a:lnRef>
-          <a:fillRef idx="3">
-            <a:schemeClr val="accent1"/>
-          </a:fillRef>
-          <a:effectRef idx="2">
-            <a:schemeClr val="accent1"/>
-          </a:effectRef>
-          <a:fontRef idx="minor">
-            <a:schemeClr val="lt1"/>
-          </a:fontRef>
-        </p:style>
-        <p:txBody>
-          <a:bodyPr rtlCol="0" anchor="ctr"/>
-          <a:lstStyle/>
-          <a:p>
-            <a:pPr algn="ctr"/>
-          </a:p>
-        </p:txBody>
-      </p:sp>
-      <p:sp>
-        <p:nvSpPr>
-          <p:cNvPr id="18" name="TextBox 17"/>
-          <p:cNvSpPr txBox="1"/>
-          <p:nvPr/>
-        </p:nvSpPr>
-        <p:spPr>
-          <a:xfrm>
-            <a:off x="713232" y="5265420"/>
-            <a:ext cx="5134356" cy="347472"/>
-          </a:xfrm>
-          <a:prstGeom prst="rect">
-            <a:avLst/>
-          </a:prstGeom>
-          <a:noFill/>
-        </p:spPr>
-        <p:txBody>
-          <a:bodyPr wrap="square"/>
-          <a:lstStyle/>
-          <a:p>
-            <a:pPr algn="l"/>
-            <a:r>
-              <a:rPr sz="1800" b="1">
-                <a:solidFill>
-                  <a:srgbClr val="2180FF"/>
-                </a:solidFill>
-                <a:latin typeface="Noto Sans"/>
-              </a:rPr>
-              <a:t>⑤JSONスキーマ設計とWebhook配信</a:t>
-            </a:r>
-          </a:p>
-        </p:txBody>
-      </p:sp>
-      <p:sp>
-        <p:nvSpPr>
-          <p:cNvPr id="19" name="TextBox 18"/>
-          <p:cNvSpPr txBox="1"/>
-          <p:nvPr/>
-        </p:nvSpPr>
-        <p:spPr>
-          <a:xfrm>
-            <a:off x="713232" y="5649468"/>
-            <a:ext cx="5134356" cy="723900"/>
-          </a:xfrm>
-          <a:prstGeom prst="rect">
-            <a:avLst/>
-          </a:prstGeom>
-          <a:noFill/>
-        </p:spPr>
-        <p:txBody>
-          <a:bodyPr wrap="square"/>
-          <a:lstStyle/>
-          <a:p>
-            <a:pPr algn="l"/>
-            <a:r>
-              <a:rPr sz="1200" b="0">
-                <a:solidFill>
-                  <a:srgbClr val="262626"/>
-                </a:solidFill>
-                <a:latin typeface="Noto Sans"/>
-              </a:rPr>
-              <a:t>SHIRAKUが期待するフィールド（質問内容・質問者・回答・回答者・スクリーンショット）＋タイムスタンプ・会議ID・話者IDをスキーマ化。Archi-Recordへの送信タイミング：議事録確定時のWebhook POST。冪等性（idempotency-key）・リトライ（最大3回・指数バックオフ）・送信ログ保持を実装。スクリーンショットの送信形式：URL参照 or Base64のどちらか確認要。</a:t>
-            </a:r>
-          </a:p>
-        </p:txBody>
-      </p:sp>
-      <p:sp>
-        <p:nvSpPr>
-          <p:cNvPr id="20" name="Rectangle 19"/>
-          <p:cNvSpPr/>
-          <p:nvPr/>
-        </p:nvSpPr>
-        <p:spPr>
-          <a:xfrm>
-            <a:off x="6176772" y="5100828"/>
-            <a:ext cx="5463540" cy="1437132"/>
-          </a:xfrm>
-          <a:prstGeom prst="rect">
-            <a:avLst/>
-          </a:prstGeom>
-          <a:solidFill>
-            <a:srgbClr val="F5F5F5"/>
-          </a:solidFill>
-          <a:ln>
-            <a:noFill/>
-          </a:ln>
-        </p:spPr>
-        <p:style>
-          <a:lnRef idx="1">
-            <a:schemeClr val="accent1"/>
-          </a:lnRef>
-          <a:fillRef idx="3">
-            <a:schemeClr val="accent1"/>
-          </a:fillRef>
-          <a:effectRef idx="2">
-            <a:schemeClr val="accent1"/>
-          </a:effectRef>
-          <a:fontRef idx="minor">
-            <a:schemeClr val="lt1"/>
-          </a:fontRef>
-        </p:style>
-        <p:txBody>
-          <a:bodyPr rtlCol="0" anchor="ctr"/>
-          <a:lstStyle/>
-          <a:p>
-            <a:pPr algn="ctr"/>
-          </a:p>
-        </p:txBody>
-      </p:sp>
-      <p:sp>
-        <p:nvSpPr>
-          <p:cNvPr id="21" name="TextBox 20"/>
-          <p:cNvSpPr txBox="1"/>
-          <p:nvPr/>
-        </p:nvSpPr>
-        <p:spPr>
-          <a:xfrm>
-            <a:off x="6341364" y="5265420"/>
-            <a:ext cx="5134356" cy="347472"/>
-          </a:xfrm>
-          <a:prstGeom prst="rect">
-            <a:avLst/>
-          </a:prstGeom>
-          <a:noFill/>
-        </p:spPr>
-        <p:txBody>
-          <a:bodyPr wrap="square"/>
-          <a:lstStyle/>
-          <a:p>
-            <a:pPr algn="l"/>
-            <a:r>
-              <a:rPr sz="1800" b="1">
-                <a:solidFill>
-                  <a:srgbClr val="2180FF"/>
-                </a:solidFill>
-                <a:latin typeface="Noto Sans"/>
-              </a:rPr>
-              <a:t>⑥プライバシー・セキュリティ設計</a:t>
-            </a:r>
-          </a:p>
-        </p:txBody>
-      </p:sp>
-      <p:sp>
-        <p:nvSpPr>
-          <p:cNvPr id="22" name="TextBox 21"/>
-          <p:cNvSpPr txBox="1"/>
-          <p:nvPr/>
-        </p:nvSpPr>
-        <p:spPr>
-          <a:xfrm>
-            <a:off x="6341364" y="5649468"/>
-            <a:ext cx="5134356" cy="723900"/>
-          </a:xfrm>
-          <a:prstGeom prst="rect">
-            <a:avLst/>
-          </a:prstGeom>
-          <a:noFill/>
-        </p:spPr>
-        <p:txBody>
-          <a:bodyPr wrap="square"/>
-          <a:lstStyle/>
-          <a:p>
-            <a:pPr algn="l"/>
-            <a:r>
-              <a:rPr sz="1200" b="0">
-                <a:solidFill>
-                  <a:srgbClr val="262626"/>
-                </a:solidFill>
-                <a:latin typeface="Noto Sans"/>
-              </a:rPr>
-              <a:t>会議映像・発言者情報は個人情報保護法（APPI）対象の可能性あり。動画は処理後即時削除（保存不要方針に合致）。スクリーンショットに含まれる参加者映像の取り扱いポリシーをSHIRAKU・Notta双方で合意。通信はTLS 1.3、保存データはAES-256暗号化。DPA（データ処理契約）の締結要否も検討。</a:t>
+              <a:t>「連携とアプリ」→「すべての連携サービス」
+　→ Archi-Recordが一覧に追加される
+　（Slack・Salesforceと同列のUI）
+オートメーション設定で：
+　アクション → 「Archi-Recordに送信」
+　オプション → 「プロジェクトを選択」</a:t>
             </a:r>
           </a:p>
         </p:txBody>
@@ -4886,7 +4506,7 @@
                 </a:solidFill>
                 <a:latin typeface="Noto Sans"/>
               </a:rPr>
-              <a:t>SHIRAKUへ確認すべき事項 ― 技術・仕様</a:t>
+              <a:t>Notta API開発で考慮すべき4テーマ</a:t>
             </a:r>
           </a:p>
         </p:txBody>
@@ -4962,7 +4582,7 @@
                 </a:solidFill>
                 <a:latin typeface="Noto Sans"/>
               </a:rPr>
-              <a:t>Archi-Record側API仕様・OAuthクライアント発行可否・スクリーンショット技術仕様の3点がAPI設計着手前の最重要確認事項</a:t>
+              <a:t>「OAuth設計」「Q&amp;A抽出」「スクリーンショット取得」「Webhook配信」がNotta側の主要開発項目</a:t>
             </a:r>
           </a:p>
         </p:txBody>
@@ -4976,16 +4596,18 @@
         <p:spPr>
           <a:xfrm>
             <a:off x="548640" y="1897380"/>
-            <a:ext cx="5463540" cy="1437132"/>
+            <a:ext cx="5463540" cy="2237994"/>
           </a:xfrm>
           <a:prstGeom prst="rect">
             <a:avLst/>
           </a:prstGeom>
           <a:solidFill>
-            <a:srgbClr val="F5F5F5"/>
+            <a:srgbClr val="FFFFFF"/>
           </a:solidFill>
-          <a:ln>
-            <a:noFill/>
+          <a:ln w="9525">
+            <a:solidFill>
+              <a:srgbClr val="E0E0E0"/>
+            </a:solidFill>
           </a:ln>
         </p:spPr>
         <p:style>
@@ -5038,7 +4660,7 @@
                 </a:solidFill>
                 <a:latin typeface="Noto Sans"/>
               </a:rPr>
-              <a:t>【確認①】Archi-Record受信API仕様</a:t>
+              <a:t>① OAuth認証フロー設計</a:t>
             </a:r>
           </a:p>
         </p:txBody>
@@ -5052,7 +4674,7 @@
         <p:spPr>
           <a:xfrm>
             <a:off x="713232" y="2446020"/>
-            <a:ext cx="5134356" cy="723900"/>
+            <a:ext cx="5134356" cy="1524762"/>
           </a:xfrm>
           <a:prstGeom prst="rect">
             <a:avLst/>
@@ -5071,7 +4693,13 @@
                 </a:solidFill>
                 <a:latin typeface="Noto Sans"/>
               </a:rPr>
-              <a:t>NottaからのJSON受信はREST API（POST）かWebhookか。エンドポイントURL・HTTPメソッド・認証方式（Bearer Token / HMAC署名 / APIキー）・レスポンスコード定義（200/400/409/429/500等）を共有いただきたい。既存のOpenAPI仕様書・Postmanコレクションがあれば提供をお願いしたい。</a:t>
+              <a:t>Archi-RecordはGoogle SSO採用
+→ Slack型OAuthとの差分設計が必要
+検討アプローチ：
+　A) Archi-RecordがNotta向けに
+　   OAuth 2.0クライアントを発行
+　B) Google IDトークンを転送して連携
+※どちらが実現可能かをSHIRAKUと確認</a:t>
             </a:r>
           </a:p>
         </p:txBody>
@@ -5085,16 +4713,18 @@
         <p:spPr>
           <a:xfrm>
             <a:off x="6176772" y="1897380"/>
-            <a:ext cx="5463540" cy="1437132"/>
+            <a:ext cx="5463540" cy="2237994"/>
           </a:xfrm>
           <a:prstGeom prst="rect">
             <a:avLst/>
           </a:prstGeom>
           <a:solidFill>
-            <a:srgbClr val="F5F5F5"/>
+            <a:srgbClr val="FFFFFF"/>
           </a:solidFill>
-          <a:ln>
-            <a:noFill/>
+          <a:ln w="9525">
+            <a:solidFill>
+              <a:srgbClr val="E0E0E0"/>
+            </a:solidFill>
           </a:ln>
         </p:spPr>
         <p:style>
@@ -5147,7 +4777,7 @@
                 </a:solidFill>
                 <a:latin typeface="Noto Sans"/>
               </a:rPr>
-              <a:t>【確認②】OAuth認証方式の詳細</a:t>
+              <a:t>② Q&amp;A構造化エンジン</a:t>
             </a:r>
           </a:p>
         </p:txBody>
@@ -5161,7 +4791,7 @@
         <p:spPr>
           <a:xfrm>
             <a:off x="6341364" y="2446020"/>
-            <a:ext cx="5134356" cy="723900"/>
+            <a:ext cx="5134356" cy="1524762"/>
           </a:xfrm>
           <a:prstGeom prst="rect">
             <a:avLst/>
@@ -5180,7 +4810,12 @@
                 </a:solidFill>
                 <a:latin typeface="Noto Sans"/>
               </a:rPr>
-              <a:t>Archi-RecordがGoogleログインを採用していることを踏まえ、Notta-Archi-Record間の認証をどう設計するか合意が必要。①Archi-RecordがNotta向けにOAuth 2.0クライアントIDを発行できるか、②既存のSlack連携でのOAuthフロー実装例・シーケンス図を共有いただけるか、③Google IDトークンの転送方式を採用する可能性があるか確認したい。</a:t>
+              <a:t>発話テキストから「質問」「回答」を自動抽出
+【LLMアプローチ】高精度・コスト高
+　→ 文脈を理解して判定
+【ルールベース】高速・低コスト
+　→ 疑問符・助詞・話者交替で判定
+建築専門用語への対応も検討が必要</a:t>
             </a:r>
           </a:p>
         </p:txBody>
@@ -5193,17 +4828,19 @@
         </p:nvSpPr>
         <p:spPr>
           <a:xfrm>
-            <a:off x="548640" y="3499104"/>
-            <a:ext cx="5463540" cy="1437132"/>
+            <a:off x="548640" y="4299966"/>
+            <a:ext cx="5463540" cy="2237994"/>
           </a:xfrm>
           <a:prstGeom prst="rect">
             <a:avLst/>
           </a:prstGeom>
           <a:solidFill>
-            <a:srgbClr val="F5F5F5"/>
+            <a:srgbClr val="FFFFFF"/>
           </a:solidFill>
-          <a:ln>
-            <a:noFill/>
+          <a:ln w="9525">
+            <a:solidFill>
+              <a:srgbClr val="E0E0E0"/>
+            </a:solidFill>
           </a:ln>
         </p:spPr>
         <p:style>
@@ -5236,7 +4873,7 @@
         </p:nvSpPr>
         <p:spPr>
           <a:xfrm>
-            <a:off x="713232" y="3663696"/>
+            <a:off x="713232" y="4464558"/>
             <a:ext cx="5134356" cy="347472"/>
           </a:xfrm>
           <a:prstGeom prst="rect">
@@ -5256,7 +4893,7 @@
                 </a:solidFill>
                 <a:latin typeface="Noto Sans"/>
               </a:rPr>
-              <a:t>【確認③】JSONフィールド詳細と命名規則</a:t>
+              <a:t>③ スクリーンショット取得</a:t>
             </a:r>
           </a:p>
         </p:txBody>
@@ -5269,8 +4906,8 @@
         </p:nvSpPr>
         <p:spPr>
           <a:xfrm>
-            <a:off x="713232" y="4047744"/>
-            <a:ext cx="5134356" cy="723900"/>
+            <a:off x="713232" y="4848606"/>
+            <a:ext cx="5134356" cy="1524762"/>
           </a:xfrm>
           <a:prstGeom prst="rect">
             <a:avLst/>
@@ -5289,7 +4926,13 @@
                 </a:solidFill>
                 <a:latin typeface="Noto Sans"/>
               </a:rPr>
-              <a:t>フィールド名の命名規則（camelCase/snake_case）・型定義・必須/任意・null許容ルール・文字数上限を確認。特にスクリーンショットはURL（CDN参照）で受け取るかBase64エンコードで受け取るかの選択、複数枚送信時の配列形式の仕様を明確にしたい。</a:t>
+              <a:t>【取得フロー】
+　① Zoom録画 or MP4ファイル取得
+　② タイムスタンプ指定でフレーム抽出
+　   （ffmpeg等で処理）
+　③ Notta CDNにアップロード → URL生成
+　④ 動画ファイルを処理後に削除
+映り込みの法的対応も確認が必要</a:t>
             </a:r>
           </a:p>
         </p:txBody>
@@ -5302,17 +4945,19 @@
         </p:nvSpPr>
         <p:spPr>
           <a:xfrm>
-            <a:off x="6176772" y="3499104"/>
-            <a:ext cx="5463540" cy="1437132"/>
+            <a:off x="6176772" y="4299966"/>
+            <a:ext cx="5463540" cy="2237994"/>
           </a:xfrm>
           <a:prstGeom prst="rect">
             <a:avLst/>
           </a:prstGeom>
           <a:solidFill>
-            <a:srgbClr val="F5F5F5"/>
+            <a:srgbClr val="FFFFFF"/>
           </a:solidFill>
-          <a:ln>
-            <a:noFill/>
+          <a:ln w="9525">
+            <a:solidFill>
+              <a:srgbClr val="E0E0E0"/>
+            </a:solidFill>
           </a:ln>
         </p:spPr>
         <p:style>
@@ -5345,7 +4990,7 @@
         </p:nvSpPr>
         <p:spPr>
           <a:xfrm>
-            <a:off x="6341364" y="3663696"/>
+            <a:off x="6341364" y="4464558"/>
             <a:ext cx="5134356" cy="347472"/>
           </a:xfrm>
           <a:prstGeom prst="rect">
@@ -5365,7 +5010,7 @@
                 </a:solidFill>
                 <a:latin typeface="Noto Sans"/>
               </a:rPr>
-              <a:t>【確認④】スクリーンショットの技術仕様</a:t>
+              <a:t>④ Webhook / JSON配信設計</a:t>
             </a:r>
           </a:p>
         </p:txBody>
@@ -5378,8 +5023,8 @@
         </p:nvSpPr>
         <p:spPr>
           <a:xfrm>
-            <a:off x="6341364" y="4047744"/>
-            <a:ext cx="5134356" cy="723900"/>
+            <a:off x="6341364" y="4848606"/>
+            <a:ext cx="5134356" cy="1524762"/>
           </a:xfrm>
           <a:prstGeom prst="rect">
             <a:avLst/>
@@ -5398,225 +5043,13 @@
                 </a:solidFill>
                 <a:latin typeface="Noto Sans"/>
               </a:rPr>
-              <a:t>Archi-RecordのAttach機能で許容される画像フォーマット（JPEG/PNG/WebP）・ファイルサイズ上限（例：1MB/枚）・解像度を確認。現資料では「基本1枚・3-5枚候補」の記載があるが、最終的に何枚をNottaから送信すべきか決定が必要。スクリーンショット選択UIをNotta側で提供するかArchi-Record側で自動選択するかも検討。</a:t>
-            </a:r>
-          </a:p>
-        </p:txBody>
-      </p:sp>
-      <p:sp>
-        <p:nvSpPr>
-          <p:cNvPr id="17" name="Rectangle 16"/>
-          <p:cNvSpPr/>
-          <p:nvPr/>
-        </p:nvSpPr>
-        <p:spPr>
-          <a:xfrm>
-            <a:off x="548640" y="5100828"/>
-            <a:ext cx="5463540" cy="1437132"/>
-          </a:xfrm>
-          <a:prstGeom prst="rect">
-            <a:avLst/>
-          </a:prstGeom>
-          <a:solidFill>
-            <a:srgbClr val="F5F5F5"/>
-          </a:solidFill>
-          <a:ln>
-            <a:noFill/>
-          </a:ln>
-        </p:spPr>
-        <p:style>
-          <a:lnRef idx="1">
-            <a:schemeClr val="accent1"/>
-          </a:lnRef>
-          <a:fillRef idx="3">
-            <a:schemeClr val="accent1"/>
-          </a:fillRef>
-          <a:effectRef idx="2">
-            <a:schemeClr val="accent1"/>
-          </a:effectRef>
-          <a:fontRef idx="minor">
-            <a:schemeClr val="lt1"/>
-          </a:fontRef>
-        </p:style>
-        <p:txBody>
-          <a:bodyPr rtlCol="0" anchor="ctr"/>
-          <a:lstStyle/>
-          <a:p>
-            <a:pPr algn="ctr"/>
-          </a:p>
-        </p:txBody>
-      </p:sp>
-      <p:sp>
-        <p:nvSpPr>
-          <p:cNvPr id="18" name="TextBox 17"/>
-          <p:cNvSpPr txBox="1"/>
-          <p:nvPr/>
-        </p:nvSpPr>
-        <p:spPr>
-          <a:xfrm>
-            <a:off x="713232" y="5265420"/>
-            <a:ext cx="5134356" cy="347472"/>
-          </a:xfrm>
-          <a:prstGeom prst="rect">
-            <a:avLst/>
-          </a:prstGeom>
-          <a:noFill/>
-        </p:spPr>
-        <p:txBody>
-          <a:bodyPr wrap="square"/>
-          <a:lstStyle/>
-          <a:p>
-            <a:pPr algn="l"/>
-            <a:r>
-              <a:rPr sz="1800" b="1">
-                <a:solidFill>
-                  <a:srgbClr val="2180FF"/>
-                </a:solidFill>
-                <a:latin typeface="Noto Sans"/>
-              </a:rPr>
-              <a:t>【確認⑤】話者名マッピング仕様</a:t>
-            </a:r>
-          </a:p>
-        </p:txBody>
-      </p:sp>
-      <p:sp>
-        <p:nvSpPr>
-          <p:cNvPr id="19" name="TextBox 18"/>
-          <p:cNvSpPr txBox="1"/>
-          <p:nvPr/>
-        </p:nvSpPr>
-        <p:spPr>
-          <a:xfrm>
-            <a:off x="713232" y="5649468"/>
-            <a:ext cx="5134356" cy="723900"/>
-          </a:xfrm>
-          <a:prstGeom prst="rect">
-            <a:avLst/>
-          </a:prstGeom>
-          <a:noFill/>
-        </p:spPr>
-        <p:txBody>
-          <a:bodyPr wrap="square"/>
-          <a:lstStyle/>
-          <a:p>
-            <a:pPr algn="l"/>
-            <a:r>
-              <a:rPr sz="1200" b="0">
-                <a:solidFill>
-                  <a:srgbClr val="262626"/>
-                </a:solidFill>
-                <a:latin typeface="Noto Sans"/>
-              </a:rPr>
-              <a:t>Pattern A（Notta Bot for Zoom）ではZoom Display Name → Archi-Recordのメンバー名への自動マッピングを想定しているが、マッピングの方法を確認。①Archi-Recordのメンバーリスト取得APIがあるか、②ユーザーが手動でマッピング設定するUIを用意するか、③Pattern B（MP4/MP3）での話者1・話者2の名前後付け編集フローをArchi-Record側でどう扱うか。</a:t>
-            </a:r>
-          </a:p>
-        </p:txBody>
-      </p:sp>
-      <p:sp>
-        <p:nvSpPr>
-          <p:cNvPr id="20" name="Rectangle 19"/>
-          <p:cNvSpPr/>
-          <p:nvPr/>
-        </p:nvSpPr>
-        <p:spPr>
-          <a:xfrm>
-            <a:off x="6176772" y="5100828"/>
-            <a:ext cx="5463540" cy="1437132"/>
-          </a:xfrm>
-          <a:prstGeom prst="rect">
-            <a:avLst/>
-          </a:prstGeom>
-          <a:solidFill>
-            <a:srgbClr val="F5F5F5"/>
-          </a:solidFill>
-          <a:ln>
-            <a:noFill/>
-          </a:ln>
-        </p:spPr>
-        <p:style>
-          <a:lnRef idx="1">
-            <a:schemeClr val="accent1"/>
-          </a:lnRef>
-          <a:fillRef idx="3">
-            <a:schemeClr val="accent1"/>
-          </a:fillRef>
-          <a:effectRef idx="2">
-            <a:schemeClr val="accent1"/>
-          </a:effectRef>
-          <a:fontRef idx="minor">
-            <a:schemeClr val="lt1"/>
-          </a:fontRef>
-        </p:style>
-        <p:txBody>
-          <a:bodyPr rtlCol="0" anchor="ctr"/>
-          <a:lstStyle/>
-          <a:p>
-            <a:pPr algn="ctr"/>
-          </a:p>
-        </p:txBody>
-      </p:sp>
-      <p:sp>
-        <p:nvSpPr>
-          <p:cNvPr id="21" name="TextBox 20"/>
-          <p:cNvSpPr txBox="1"/>
-          <p:nvPr/>
-        </p:nvSpPr>
-        <p:spPr>
-          <a:xfrm>
-            <a:off x="6341364" y="5265420"/>
-            <a:ext cx="5134356" cy="347472"/>
-          </a:xfrm>
-          <a:prstGeom prst="rect">
-            <a:avLst/>
-          </a:prstGeom>
-          <a:noFill/>
-        </p:spPr>
-        <p:txBody>
-          <a:bodyPr wrap="square"/>
-          <a:lstStyle/>
-          <a:p>
-            <a:pPr algn="l"/>
-            <a:r>
-              <a:rPr sz="1800" b="1">
-                <a:solidFill>
-                  <a:srgbClr val="2180FF"/>
-                </a:solidFill>
-                <a:latin typeface="Noto Sans"/>
-              </a:rPr>
-              <a:t>【確認⑥】Archi-Recordシステム構成とSLA</a:t>
-            </a:r>
-          </a:p>
-        </p:txBody>
-      </p:sp>
-      <p:sp>
-        <p:nvSpPr>
-          <p:cNvPr id="22" name="TextBox 21"/>
-          <p:cNvSpPr txBox="1"/>
-          <p:nvPr/>
-        </p:nvSpPr>
-        <p:spPr>
-          <a:xfrm>
-            <a:off x="6341364" y="5649468"/>
-            <a:ext cx="5134356" cy="723900"/>
-          </a:xfrm>
-          <a:prstGeom prst="rect">
-            <a:avLst/>
-          </a:prstGeom>
-          <a:noFill/>
-        </p:spPr>
-        <p:txBody>
-          <a:bodyPr wrap="square"/>
-          <a:lstStyle/>
-          <a:p>
-            <a:pPr algn="l"/>
-            <a:r>
-              <a:rPr sz="1200" b="0">
-                <a:solidFill>
-                  <a:srgbClr val="262626"/>
-                </a:solidFill>
-                <a:latin typeface="Noto Sans"/>
-              </a:rPr>
-              <a:t>クラウドSaaSかオンプレミスかを確認。API rate limit（リクエスト数/分）・同時接続数上限・レスポンスタイムSLA（例：P95で3秒以内）・メンテナンス時間帯の通知方法。テスト・E2E検証に向けたサンドボックス環境の提供可否。本番移行後の月間会議件数・データ量の見込みも共有いただきたい。</a:t>
+              <a:t>【送信タイミング】議事録確定時に自動POST
+設計上の考慮点：
+　• 冪等性（二重送信防止）
+　• リトライ（最大3回・指数バックオフ）
+　• 送信ログの保持
+スクリーンショットの送信形式：
+　URLリンク or Base64？→ SHIRAKU確認要</a:t>
             </a:r>
           </a:p>
         </p:txBody>
@@ -5675,7 +5108,7 @@
                 </a:solidFill>
                 <a:latin typeface="Noto Sans"/>
               </a:rPr>
-              <a:t>SHIRAKUへ確認すべき事項 ― 業務・スケジュール</a:t>
+              <a:t>SHIRAKUへ確認したいこと ― 技術・仕様編</a:t>
             </a:r>
           </a:p>
         </p:txBody>
@@ -5751,7 +5184,7 @@
                 </a:solidFill>
                 <a:latin typeface="Noto Sans"/>
               </a:rPr>
-              <a:t>PoCスコープと成功KPIの早期合意により両社の開発リソースを適切に配置し、品質目標と検証期間を確定する</a:t>
+              <a:t>API仕様・OAuth・スクリーンショット技術仕様・話者マッピングの4点を先に確定することが開発着手の前提</a:t>
             </a:r>
           </a:p>
         </p:txBody>
@@ -5765,16 +5198,18 @@
         <p:spPr>
           <a:xfrm>
             <a:off x="548640" y="1897380"/>
-            <a:ext cx="5463540" cy="1437132"/>
+            <a:ext cx="5463540" cy="2237994"/>
           </a:xfrm>
           <a:prstGeom prst="rect">
             <a:avLst/>
           </a:prstGeom>
           <a:solidFill>
-            <a:srgbClr val="F5F5F5"/>
+            <a:srgbClr val="FFFFFF"/>
           </a:solidFill>
-          <a:ln>
-            <a:noFill/>
+          <a:ln w="9525">
+            <a:solidFill>
+              <a:srgbClr val="E0E0E0"/>
+            </a:solidFill>
           </a:ln>
         </p:spPr>
         <p:style>
@@ -5827,7 +5262,7 @@
                 </a:solidFill>
                 <a:latin typeface="Noto Sans"/>
               </a:rPr>
-              <a:t>【確認⑦】PoCスコープと対象シナリオ</a:t>
+              <a:t>確認① Archi-Record受信API仕様</a:t>
             </a:r>
           </a:p>
         </p:txBody>
@@ -5841,7 +5276,7 @@
         <p:spPr>
           <a:xfrm>
             <a:off x="713232" y="2446020"/>
-            <a:ext cx="5134356" cy="723900"/>
+            <a:ext cx="5134356" cy="1524762"/>
           </a:xfrm>
           <a:prstGeom prst="rect">
             <a:avLst/>
@@ -5860,7 +5295,12 @@
                 </a:solidFill>
                 <a:latin typeface="Noto Sans"/>
               </a:rPr>
-              <a:t>PoC対象とする会議の種類（現場確認会議・設計打ち合わせ等）・件数・参加者数上限。Pattern A（Notta Bot）とPattern B（MP4/MP3アップロード）のどちらを先行検証するか。Archi-RecordのCheck Listテンプレートの種類（建築確認/工程管理等）とQ&amp;Aペアの想定件数（1会議あたり平均何件）を共有いただきたい。</a:t>
+              <a:t>• REST API（POST）かWebhookか？
+• エンドポイントURL・認証方式は？
+   （Bearer Token / HMAC署名 / APIキー）
+• レスポンスコード定義（200/400/409等）
+• OpenAPI仕様書・Postmanコレクション
+  があれば共有をお願いしたい</a:t>
             </a:r>
           </a:p>
         </p:txBody>
@@ -5874,16 +5314,18 @@
         <p:spPr>
           <a:xfrm>
             <a:off x="6176772" y="1897380"/>
-            <a:ext cx="5463540" cy="1437132"/>
+            <a:ext cx="5463540" cy="2237994"/>
           </a:xfrm>
           <a:prstGeom prst="rect">
             <a:avLst/>
           </a:prstGeom>
           <a:solidFill>
-            <a:srgbClr val="F5F5F5"/>
+            <a:srgbClr val="FFFFFF"/>
           </a:solidFill>
-          <a:ln>
-            <a:noFill/>
+          <a:ln w="9525">
+            <a:solidFill>
+              <a:srgbClr val="E0E0E0"/>
+            </a:solidFill>
           </a:ln>
         </p:spPr>
         <p:style>
@@ -5936,7 +5378,7 @@
                 </a:solidFill>
                 <a:latin typeface="Noto Sans"/>
               </a:rPr>
-              <a:t>【確認⑧】自動入力の期待精度と承認フロー</a:t>
+              <a:t>確認② OAuth認証方式の詳細</a:t>
             </a:r>
           </a:p>
         </p:txBody>
@@ -5950,7 +5392,7 @@
         <p:spPr>
           <a:xfrm>
             <a:off x="6341364" y="2446020"/>
-            <a:ext cx="5134356" cy="723900"/>
+            <a:ext cx="5134356" cy="1524762"/>
           </a:xfrm>
           <a:prstGeom prst="rect">
             <a:avLst/>
@@ -5969,7 +5411,13 @@
                 </a:solidFill>
                 <a:latin typeface="Noto Sans"/>
               </a:rPr>
-              <a:t>Q&amp;A抽出・チェックリスト自動入力の精度目標（例：適合率80%以上）を確認。誤入力・誤認識時の修正フロー（ユーザーが手動修正 or Nottaへ再送信要求）と、人間承認ステップの要否（確認後自動反映 / 即時反映の2モード）を取り決めたい。建築専門用語・プロジェクト固有名詞の精度向上策も議論したい。</a:t>
+              <a:t>• Notta向けにOAuth 2.0クライアントID
+  を発行できるか？
+• 既存Slack連携のOAuthフロー・
+  シーケンス図を共有いただけるか？
+• Google IDトークン転送方式は
+  採用可能か？
+→ 認証設計の最重要確認事項</a:t>
             </a:r>
           </a:p>
         </p:txBody>
@@ -5982,17 +5430,19 @@
         </p:nvSpPr>
         <p:spPr>
           <a:xfrm>
-            <a:off x="548640" y="3499104"/>
-            <a:ext cx="5463540" cy="1437132"/>
+            <a:off x="548640" y="4299966"/>
+            <a:ext cx="5463540" cy="2237994"/>
           </a:xfrm>
           <a:prstGeom prst="rect">
             <a:avLst/>
           </a:prstGeom>
           <a:solidFill>
-            <a:srgbClr val="F5F5F5"/>
+            <a:srgbClr val="FFFFFF"/>
           </a:solidFill>
-          <a:ln>
-            <a:noFill/>
+          <a:ln w="9525">
+            <a:solidFill>
+              <a:srgbClr val="E0E0E0"/>
+            </a:solidFill>
           </a:ln>
         </p:spPr>
         <p:style>
@@ -6025,7 +5475,7 @@
         </p:nvSpPr>
         <p:spPr>
           <a:xfrm>
-            <a:off x="713232" y="3663696"/>
+            <a:off x="713232" y="4464558"/>
             <a:ext cx="5134356" cy="347472"/>
           </a:xfrm>
           <a:prstGeom prst="rect">
@@ -6045,7 +5495,7 @@
                 </a:solidFill>
                 <a:latin typeface="Noto Sans"/>
               </a:rPr>
-              <a:t>【確認⑨】スケジュール・マイルストーン</a:t>
+              <a:t>確認③ スクリーンショット技術仕様</a:t>
             </a:r>
           </a:p>
         </p:txBody>
@@ -6058,8 +5508,8 @@
         </p:nvSpPr>
         <p:spPr>
           <a:xfrm>
-            <a:off x="713232" y="4047744"/>
-            <a:ext cx="5134356" cy="723900"/>
+            <a:off x="713232" y="4848606"/>
+            <a:ext cx="5134356" cy="1524762"/>
           </a:xfrm>
           <a:prstGeom prst="rect">
             <a:avLst/>
@@ -6078,7 +5528,13 @@
                 </a:solidFill>
                 <a:latin typeface="Noto Sans"/>
               </a:rPr>
-              <a:t>【M1】API仕様・JSONスキーマ合意、【M2】OAuth認証フロー実装・単体テスト完了、【M3】Q&amp;A構造化+スクリーンショット取得実装完了、【M4】Archi-Record側アダプター実装・結合テスト、【M5】E2Eテスト・PoC本番開始・評価。各マイルストーンの目標日程をSHIRAKUと合意したい。</a:t>
+              <a:t>• Attach機能の対応フォーマット？
+  （JPEG / PNG / WebP）
+• 1ファイルあたりサイズ上限は？
+• 最終的に何枚送信すればよい？
+  （現資料：基本1枚 / 候補3-5枚）
+• Notta側で枚数選択UIを提供するか
+  Archi-Record側で自動選択するか？</a:t>
             </a:r>
           </a:p>
         </p:txBody>
@@ -6091,17 +5547,19 @@
         </p:nvSpPr>
         <p:spPr>
           <a:xfrm>
-            <a:off x="6176772" y="3499104"/>
-            <a:ext cx="5463540" cy="1437132"/>
+            <a:off x="6176772" y="4299966"/>
+            <a:ext cx="5463540" cy="2237994"/>
           </a:xfrm>
           <a:prstGeom prst="rect">
             <a:avLst/>
           </a:prstGeom>
           <a:solidFill>
-            <a:srgbClr val="F5F5F5"/>
+            <a:srgbClr val="FFFFFF"/>
           </a:solidFill>
-          <a:ln>
-            <a:noFill/>
+          <a:ln w="9525">
+            <a:solidFill>
+              <a:srgbClr val="E0E0E0"/>
+            </a:solidFill>
           </a:ln>
         </p:spPr>
         <p:style>
@@ -6134,7 +5592,7 @@
         </p:nvSpPr>
         <p:spPr>
           <a:xfrm>
-            <a:off x="6341364" y="3663696"/>
+            <a:off x="6341364" y="4464558"/>
             <a:ext cx="5134356" cy="347472"/>
           </a:xfrm>
           <a:prstGeom prst="rect">
@@ -6154,7 +5612,7 @@
                 </a:solidFill>
                 <a:latin typeface="Noto Sans"/>
               </a:rPr>
-              <a:t>【確認⑩】Slack連携の実装詳細共有</a:t>
+              <a:t>確認④ 話者名マッピング仕様</a:t>
             </a:r>
           </a:p>
         </p:txBody>
@@ -6167,8 +5625,8 @@
         </p:nvSpPr>
         <p:spPr>
           <a:xfrm>
-            <a:off x="6341364" y="4047744"/>
-            <a:ext cx="5134356" cy="723900"/>
+            <a:off x="6341364" y="4848606"/>
+            <a:ext cx="5134356" cy="1524762"/>
           </a:xfrm>
           <a:prstGeom prst="rect">
             <a:avLst/>
@@ -6187,27 +5645,92 @@
                 </a:solidFill>
                 <a:latin typeface="Noto Sans"/>
               </a:rPr>
-              <a:t>NottaにはSlack連携が既に実装されているため、Archi-Record連携のOAuthフロー設計参考として実装例を共有。SHIRAKU側でも既存Slack連携があればOAuth設計・シーケンス図・API設計パターンをNotta側に提供いただけると開発効率が上がる。共有形式（Notion / GitHub / OpenAPI仕様書等）を確認。</a:t>
-            </a:r>
-          </a:p>
-        </p:txBody>
-      </p:sp>
-      <p:sp>
-        <p:nvSpPr>
-          <p:cNvPr id="17" name="Rectangle 16"/>
+              <a:t>Pattern A（Notta Bot）の場合：
+　Zoom表示名 → Archi-Recordメンバー名
+　に自動マッピングするための
+　メンバーリスト取得APIはあるか？
+Pattern B（MP4/MP3）の場合：
+　「話者1・話者2」→ 名前編集後に
+　Archi-Recordへ反映するフローは？</a:t>
+            </a:r>
+          </a:p>
+        </p:txBody>
+      </p:sp>
+    </p:spTree>
+  </p:cSld>
+  <p:clrMapOvr>
+    <a:masterClrMapping/>
+  </p:clrMapOvr>
+</p:sld>
+</file>
+
+<file path=ppt/slides/slide6.xml><?xml version="1.0" encoding="utf-8"?>
+<p:sld xmlns:a="http://schemas.openxmlformats.org/drawingml/2006/main" xmlns:p="http://schemas.openxmlformats.org/presentationml/2006/main" xmlns:r="http://schemas.openxmlformats.org/officeDocument/2006/relationships">
+  <p:cSld>
+    <p:bg>
+      <p:bgPr>
+        <a:solidFill>
+          <a:srgbClr val="FFFFFF"/>
+        </a:solidFill>
+        <a:effectLst/>
+      </p:bgPr>
+    </p:bg>
+    <p:spTree>
+      <p:nvGrpSpPr>
+        <p:cNvPr id="1" name=""/>
+        <p:cNvGrpSpPr/>
+        <p:nvPr/>
+      </p:nvGrpSpPr>
+      <p:grpSpPr/>
+      <p:sp>
+        <p:nvSpPr>
+          <p:cNvPr id="2" name="TextBox 1"/>
+          <p:cNvSpPr txBox="1"/>
+          <p:nvPr/>
+        </p:nvSpPr>
+        <p:spPr>
+          <a:xfrm>
+            <a:off x="548640" y="320040"/>
+            <a:ext cx="11091672" cy="411480"/>
+          </a:xfrm>
+          <a:prstGeom prst="rect">
+            <a:avLst/>
+          </a:prstGeom>
+          <a:noFill/>
+        </p:spPr>
+        <p:txBody>
+          <a:bodyPr wrap="square"/>
+          <a:lstStyle/>
+          <a:p>
+            <a:pPr algn="l"/>
+            <a:r>
+              <a:rPr sz="1600" b="0">
+                <a:solidFill>
+                  <a:srgbClr val="2180FF"/>
+                </a:solidFill>
+                <a:latin typeface="Noto Sans"/>
+              </a:rPr>
+              <a:t>SHIRAKUへ確認したいこと ― 業務・スケジュール編</a:t>
+            </a:r>
+          </a:p>
+        </p:txBody>
+      </p:sp>
+      <p:sp>
+        <p:nvSpPr>
+          <p:cNvPr id="3" name="Rectangle 2"/>
           <p:cNvSpPr/>
           <p:nvPr/>
         </p:nvSpPr>
         <p:spPr>
           <a:xfrm>
-            <a:off x="548640" y="5100828"/>
-            <a:ext cx="5463540" cy="1437132"/>
+            <a:off x="548640" y="841248"/>
+            <a:ext cx="11091672" cy="13716"/>
           </a:xfrm>
           <a:prstGeom prst="rect">
             <a:avLst/>
           </a:prstGeom>
           <a:solidFill>
-            <a:srgbClr val="F5F5F5"/>
+            <a:srgbClr val="D0D0D0"/>
           </a:solidFill>
           <a:ln>
             <a:noFill/>
@@ -6237,14 +5760,14 @@
       </p:sp>
       <p:sp>
         <p:nvSpPr>
-          <p:cNvPr id="18" name="TextBox 17"/>
+          <p:cNvPr id="4" name="TextBox 3"/>
           <p:cNvSpPr txBox="1"/>
           <p:nvPr/>
         </p:nvSpPr>
         <p:spPr>
           <a:xfrm>
-            <a:off x="713232" y="5265420"/>
-            <a:ext cx="5134356" cy="347472"/>
+            <a:off x="548640" y="982980"/>
+            <a:ext cx="11091672" cy="685800"/>
           </a:xfrm>
           <a:prstGeom prst="rect">
             <a:avLst/>
@@ -6257,69 +5780,38 @@
           <a:p>
             <a:pPr algn="l"/>
             <a:r>
-              <a:rPr sz="1800" b="1">
-                <a:solidFill>
-                  <a:srgbClr val="2180FF"/>
+              <a:rPr sz="2000" b="1">
+                <a:solidFill>
+                  <a:srgbClr val="262626"/>
                 </a:solidFill>
                 <a:latin typeface="Noto Sans"/>
               </a:rPr>
-              <a:t>【確認⑪】データ利用・プライバシー・契約</a:t>
-            </a:r>
-          </a:p>
-        </p:txBody>
-      </p:sp>
-      <p:sp>
-        <p:nvSpPr>
-          <p:cNvPr id="19" name="TextBox 18"/>
-          <p:cNvSpPr txBox="1"/>
-          <p:nvPr/>
-        </p:nvSpPr>
-        <p:spPr>
-          <a:xfrm>
-            <a:off x="713232" y="5649468"/>
-            <a:ext cx="5134356" cy="723900"/>
-          </a:xfrm>
-          <a:prstGeom prst="rect">
-            <a:avLst/>
-          </a:prstGeom>
-          <a:noFill/>
-        </p:spPr>
-        <p:txBody>
-          <a:bodyPr wrap="square"/>
-          <a:lstStyle/>
-          <a:p>
-            <a:pPr algn="l"/>
-            <a:r>
-              <a:rPr sz="1200" b="0">
-                <a:solidFill>
-                  <a:srgbClr val="262626"/>
-                </a:solidFill>
-                <a:latin typeface="Noto Sans"/>
-              </a:rPr>
-              <a:t>会議映像（スクリーンショット取得後は削除想定）・議事録テキスト・発言者情報の二次利用範囲（AI学習利用の可否等）。NDA・DPA（データ処理契約）の締結要否。建築現場の映像に含まれる未公開図面・設計情報の機密扱い。個人情報保護法（APPI）準拠の対応方針をSHIRAKU側で確認済みかどうか。</a:t>
-            </a:r>
-          </a:p>
-        </p:txBody>
-      </p:sp>
-      <p:sp>
-        <p:nvSpPr>
-          <p:cNvPr id="20" name="Rectangle 19"/>
+              <a:t>PoCスコープと成功KPIの早期合意で、両社の開発リソースを適切に配置する</a:t>
+            </a:r>
+          </a:p>
+        </p:txBody>
+      </p:sp>
+      <p:sp>
+        <p:nvSpPr>
+          <p:cNvPr id="5" name="Rectangle 4"/>
           <p:cNvSpPr/>
           <p:nvPr/>
         </p:nvSpPr>
         <p:spPr>
           <a:xfrm>
-            <a:off x="6176772" y="5100828"/>
-            <a:ext cx="5463540" cy="1437132"/>
+            <a:off x="548640" y="1897380"/>
+            <a:ext cx="5463540" cy="2237994"/>
           </a:xfrm>
           <a:prstGeom prst="rect">
             <a:avLst/>
           </a:prstGeom>
           <a:solidFill>
-            <a:srgbClr val="F5F5F5"/>
+            <a:srgbClr val="FFFFFF"/>
           </a:solidFill>
-          <a:ln>
-            <a:noFill/>
+          <a:ln w="9525">
+            <a:solidFill>
+              <a:srgbClr val="E0E0E0"/>
+            </a:solidFill>
           </a:ln>
         </p:spPr>
         <p:style>
@@ -6346,13 +5838,13 @@
       </p:sp>
       <p:sp>
         <p:nvSpPr>
-          <p:cNvPr id="21" name="TextBox 20"/>
+          <p:cNvPr id="6" name="TextBox 5"/>
           <p:cNvSpPr txBox="1"/>
           <p:nvPr/>
         </p:nvSpPr>
         <p:spPr>
           <a:xfrm>
-            <a:off x="6341364" y="5265420"/>
+            <a:off x="713232" y="2061972"/>
             <a:ext cx="5134356" cy="347472"/>
           </a:xfrm>
           <a:prstGeom prst="rect">
@@ -6372,21 +5864,21 @@
                 </a:solidFill>
                 <a:latin typeface="Noto Sans"/>
               </a:rPr>
-              <a:t>【確認⑫】窓口・体制・意思決定フロー</a:t>
-            </a:r>
-          </a:p>
-        </p:txBody>
-      </p:sp>
-      <p:sp>
-        <p:nvSpPr>
-          <p:cNvPr id="22" name="TextBox 21"/>
+              <a:t>確認⑤ PoCスコープ</a:t>
+            </a:r>
+          </a:p>
+        </p:txBody>
+      </p:sp>
+      <p:sp>
+        <p:nvSpPr>
+          <p:cNvPr id="7" name="TextBox 6"/>
           <p:cNvSpPr txBox="1"/>
           <p:nvPr/>
         </p:nvSpPr>
         <p:spPr>
           <a:xfrm>
-            <a:off x="6341364" y="5649468"/>
-            <a:ext cx="5134356" cy="723900"/>
+            <a:off x="713232" y="2446020"/>
+            <a:ext cx="5134356" cy="1524762"/>
           </a:xfrm>
           <a:prstGeom prst="rect">
             <a:avLst/>
@@ -6405,7 +5897,362 @@
                 </a:solidFill>
                 <a:latin typeface="Noto Sans"/>
               </a:rPr>
-              <a:t>技術担当（APIスキーマ・インフラ担当）とビジネス担当（要件・契約担当）の連絡先確認。仕様変更・追加要望の受付フロー（GitHubイシュー / Notion / メール等）・意思決定者の特定。定期進捗MTGの頻度・形式（週次/隔週/Zoom）・初回キックオフの日程候補を決定したい。</a:t>
+              <a:t>• 対象会議の種類・件数・参加者数上限
+• Pattern A / B どちらを先行検証？
+• テスト対象のチェックリスト
+  テンプレート種類は？
+• 1会議あたりのQ&amp;Aペア平均件数は？
+• PoC開始に向けたサンドボックス環境は
+  提供可能か？</a:t>
+            </a:r>
+          </a:p>
+        </p:txBody>
+      </p:sp>
+      <p:sp>
+        <p:nvSpPr>
+          <p:cNvPr id="8" name="Rectangle 7"/>
+          <p:cNvSpPr/>
+          <p:nvPr/>
+        </p:nvSpPr>
+        <p:spPr>
+          <a:xfrm>
+            <a:off x="6176772" y="1897380"/>
+            <a:ext cx="5463540" cy="2237994"/>
+          </a:xfrm>
+          <a:prstGeom prst="rect">
+            <a:avLst/>
+          </a:prstGeom>
+          <a:solidFill>
+            <a:srgbClr val="FFFFFF"/>
+          </a:solidFill>
+          <a:ln w="9525">
+            <a:solidFill>
+              <a:srgbClr val="E0E0E0"/>
+            </a:solidFill>
+          </a:ln>
+        </p:spPr>
+        <p:style>
+          <a:lnRef idx="1">
+            <a:schemeClr val="accent1"/>
+          </a:lnRef>
+          <a:fillRef idx="3">
+            <a:schemeClr val="accent1"/>
+          </a:fillRef>
+          <a:effectRef idx="2">
+            <a:schemeClr val="accent1"/>
+          </a:effectRef>
+          <a:fontRef idx="minor">
+            <a:schemeClr val="lt1"/>
+          </a:fontRef>
+        </p:style>
+        <p:txBody>
+          <a:bodyPr rtlCol="0" anchor="ctr"/>
+          <a:lstStyle/>
+          <a:p>
+            <a:pPr algn="ctr"/>
+          </a:p>
+        </p:txBody>
+      </p:sp>
+      <p:sp>
+        <p:nvSpPr>
+          <p:cNvPr id="9" name="TextBox 8"/>
+          <p:cNvSpPr txBox="1"/>
+          <p:nvPr/>
+        </p:nvSpPr>
+        <p:spPr>
+          <a:xfrm>
+            <a:off x="6341364" y="2061972"/>
+            <a:ext cx="5134356" cy="347472"/>
+          </a:xfrm>
+          <a:prstGeom prst="rect">
+            <a:avLst/>
+          </a:prstGeom>
+          <a:noFill/>
+        </p:spPr>
+        <p:txBody>
+          <a:bodyPr wrap="square"/>
+          <a:lstStyle/>
+          <a:p>
+            <a:pPr algn="l"/>
+            <a:r>
+              <a:rPr sz="1800" b="1">
+                <a:solidFill>
+                  <a:srgbClr val="2180FF"/>
+                </a:solidFill>
+                <a:latin typeface="Noto Sans"/>
+              </a:rPr>
+              <a:t>確認⑥ 自動入力の精度目標・承認フロー</a:t>
+            </a:r>
+          </a:p>
+        </p:txBody>
+      </p:sp>
+      <p:sp>
+        <p:nvSpPr>
+          <p:cNvPr id="10" name="TextBox 9"/>
+          <p:cNvSpPr txBox="1"/>
+          <p:nvPr/>
+        </p:nvSpPr>
+        <p:spPr>
+          <a:xfrm>
+            <a:off x="6341364" y="2446020"/>
+            <a:ext cx="5134356" cy="1524762"/>
+          </a:xfrm>
+          <a:prstGeom prst="rect">
+            <a:avLst/>
+          </a:prstGeom>
+          <a:noFill/>
+        </p:spPr>
+        <p:txBody>
+          <a:bodyPr wrap="square"/>
+          <a:lstStyle/>
+          <a:p>
+            <a:pPr algn="l"/>
+            <a:r>
+              <a:rPr sz="1200" b="0">
+                <a:solidFill>
+                  <a:srgbClr val="262626"/>
+                </a:solidFill>
+                <a:latin typeface="Noto Sans"/>
+              </a:rPr>
+              <a:t>• Q&amp;A抽出・チェックリスト入力の
+  精度目標は？（例：適合率80%以上）
+• 誤入力時の修正フローは？
+   A) ユーザーが手動修正
+   B) Nottaへ再送信を要求
+• 人間承認ステップは必要か？
+   → 確認後自動反映 / 即時反映？</a:t>
+            </a:r>
+          </a:p>
+        </p:txBody>
+      </p:sp>
+      <p:sp>
+        <p:nvSpPr>
+          <p:cNvPr id="11" name="Rectangle 10"/>
+          <p:cNvSpPr/>
+          <p:nvPr/>
+        </p:nvSpPr>
+        <p:spPr>
+          <a:xfrm>
+            <a:off x="548640" y="4299966"/>
+            <a:ext cx="5463540" cy="2237994"/>
+          </a:xfrm>
+          <a:prstGeom prst="rect">
+            <a:avLst/>
+          </a:prstGeom>
+          <a:solidFill>
+            <a:srgbClr val="FFFFFF"/>
+          </a:solidFill>
+          <a:ln w="9525">
+            <a:solidFill>
+              <a:srgbClr val="E0E0E0"/>
+            </a:solidFill>
+          </a:ln>
+        </p:spPr>
+        <p:style>
+          <a:lnRef idx="1">
+            <a:schemeClr val="accent1"/>
+          </a:lnRef>
+          <a:fillRef idx="3">
+            <a:schemeClr val="accent1"/>
+          </a:fillRef>
+          <a:effectRef idx="2">
+            <a:schemeClr val="accent1"/>
+          </a:effectRef>
+          <a:fontRef idx="minor">
+            <a:schemeClr val="lt1"/>
+          </a:fontRef>
+        </p:style>
+        <p:txBody>
+          <a:bodyPr rtlCol="0" anchor="ctr"/>
+          <a:lstStyle/>
+          <a:p>
+            <a:pPr algn="ctr"/>
+          </a:p>
+        </p:txBody>
+      </p:sp>
+      <p:sp>
+        <p:nvSpPr>
+          <p:cNvPr id="12" name="TextBox 11"/>
+          <p:cNvSpPr txBox="1"/>
+          <p:nvPr/>
+        </p:nvSpPr>
+        <p:spPr>
+          <a:xfrm>
+            <a:off x="713232" y="4464558"/>
+            <a:ext cx="5134356" cy="347472"/>
+          </a:xfrm>
+          <a:prstGeom prst="rect">
+            <a:avLst/>
+          </a:prstGeom>
+          <a:noFill/>
+        </p:spPr>
+        <p:txBody>
+          <a:bodyPr wrap="square"/>
+          <a:lstStyle/>
+          <a:p>
+            <a:pPr algn="l"/>
+            <a:r>
+              <a:rPr sz="1800" b="1">
+                <a:solidFill>
+                  <a:srgbClr val="2180FF"/>
+                </a:solidFill>
+                <a:latin typeface="Noto Sans"/>
+              </a:rPr>
+              <a:t>確認⑦ マイルストーン・スケジュール</a:t>
+            </a:r>
+          </a:p>
+        </p:txBody>
+      </p:sp>
+      <p:sp>
+        <p:nvSpPr>
+          <p:cNvPr id="13" name="TextBox 12"/>
+          <p:cNvSpPr txBox="1"/>
+          <p:nvPr/>
+        </p:nvSpPr>
+        <p:spPr>
+          <a:xfrm>
+            <a:off x="713232" y="4848606"/>
+            <a:ext cx="5134356" cy="1524762"/>
+          </a:xfrm>
+          <a:prstGeom prst="rect">
+            <a:avLst/>
+          </a:prstGeom>
+          <a:noFill/>
+        </p:spPr>
+        <p:txBody>
+          <a:bodyPr wrap="square"/>
+          <a:lstStyle/>
+          <a:p>
+            <a:pPr algn="l"/>
+            <a:r>
+              <a:rPr sz="1200" b="0">
+                <a:solidFill>
+                  <a:srgbClr val="262626"/>
+                </a:solidFill>
+                <a:latin typeface="Noto Sans"/>
+              </a:rPr>
+              <a:t>【M1】API仕様・JSONスキーマ合意
+【M2】OAuth認証フロー実装完了
+【M3】Q&amp;A構造化 + スクショ取得完了
+【M4】結合テスト・E2E検証
+【M5】PoC本番開始・評価
+→ 各マイルストーンの目標日を確定したい</a:t>
+            </a:r>
+          </a:p>
+        </p:txBody>
+      </p:sp>
+      <p:sp>
+        <p:nvSpPr>
+          <p:cNvPr id="14" name="Rectangle 13"/>
+          <p:cNvSpPr/>
+          <p:nvPr/>
+        </p:nvSpPr>
+        <p:spPr>
+          <a:xfrm>
+            <a:off x="6176772" y="4299966"/>
+            <a:ext cx="5463540" cy="2237994"/>
+          </a:xfrm>
+          <a:prstGeom prst="rect">
+            <a:avLst/>
+          </a:prstGeom>
+          <a:solidFill>
+            <a:srgbClr val="FFFFFF"/>
+          </a:solidFill>
+          <a:ln w="9525">
+            <a:solidFill>
+              <a:srgbClr val="E0E0E0"/>
+            </a:solidFill>
+          </a:ln>
+        </p:spPr>
+        <p:style>
+          <a:lnRef idx="1">
+            <a:schemeClr val="accent1"/>
+          </a:lnRef>
+          <a:fillRef idx="3">
+            <a:schemeClr val="accent1"/>
+          </a:fillRef>
+          <a:effectRef idx="2">
+            <a:schemeClr val="accent1"/>
+          </a:effectRef>
+          <a:fontRef idx="minor">
+            <a:schemeClr val="lt1"/>
+          </a:fontRef>
+        </p:style>
+        <p:txBody>
+          <a:bodyPr rtlCol="0" anchor="ctr"/>
+          <a:lstStyle/>
+          <a:p>
+            <a:pPr algn="ctr"/>
+          </a:p>
+        </p:txBody>
+      </p:sp>
+      <p:sp>
+        <p:nvSpPr>
+          <p:cNvPr id="15" name="TextBox 14"/>
+          <p:cNvSpPr txBox="1"/>
+          <p:nvPr/>
+        </p:nvSpPr>
+        <p:spPr>
+          <a:xfrm>
+            <a:off x="6341364" y="4464558"/>
+            <a:ext cx="5134356" cy="347472"/>
+          </a:xfrm>
+          <a:prstGeom prst="rect">
+            <a:avLst/>
+          </a:prstGeom>
+          <a:noFill/>
+        </p:spPr>
+        <p:txBody>
+          <a:bodyPr wrap="square"/>
+          <a:lstStyle/>
+          <a:p>
+            <a:pPr algn="l"/>
+            <a:r>
+              <a:rPr sz="1800" b="1">
+                <a:solidFill>
+                  <a:srgbClr val="2180FF"/>
+                </a:solidFill>
+                <a:latin typeface="Noto Sans"/>
+              </a:rPr>
+              <a:t>確認⑧ 体制・契約・窓口</a:t>
+            </a:r>
+          </a:p>
+        </p:txBody>
+      </p:sp>
+      <p:sp>
+        <p:nvSpPr>
+          <p:cNvPr id="16" name="TextBox 15"/>
+          <p:cNvSpPr txBox="1"/>
+          <p:nvPr/>
+        </p:nvSpPr>
+        <p:spPr>
+          <a:xfrm>
+            <a:off x="6341364" y="4848606"/>
+            <a:ext cx="5134356" cy="1524762"/>
+          </a:xfrm>
+          <a:prstGeom prst="rect">
+            <a:avLst/>
+          </a:prstGeom>
+          <a:noFill/>
+        </p:spPr>
+        <p:txBody>
+          <a:bodyPr wrap="square"/>
+          <a:lstStyle/>
+          <a:p>
+            <a:pPr algn="l"/>
+            <a:r>
+              <a:rPr sz="1200" b="0">
+                <a:solidFill>
+                  <a:srgbClr val="262626"/>
+                </a:solidFill>
+                <a:latin typeface="Noto Sans"/>
+              </a:rPr>
+              <a:t>• 技術担当 / ビジネス担当の連絡先
+• 仕様変更の受付フロー
+  （Notion / GitHub / メール等）
+• データ利用・NDA・DPA締結の要否
+  ※映像・発言者情報の個人情報扱い
+• 定期MTGの頻度・初回キックオフ日程</a:t>
             </a:r>
           </a:p>
         </p:txBody>

</xml_diff>

<commit_message>
Update SHIRAKU discussion paper to align with Notta API v0.4 spec
- Flag Bot dispatch and File Upload API as v1 out-of-scope (v2 planned)
- Clarify Q&A structuring and screenshot features are not in API v0.4 spec
- Replace push-model assumption with pull-model architecture (webhook notification + Archi-Record calls Notta API)
- Add metadata-based project linking (archi_record_project_id) as core integration pattern
- Fix webhook retry count: 3 times → 4 times (5min/30min/2h/24h)
- Add new slide for Notta API v1 scope summary
- Update SHIRAKU confirmation items to reflect v1 constraints

https://claude.ai/code/session_01TRkHFS2izteTGUG9tXtCZE
</commit_message>
<xml_diff>
--- a/shiraku_notta_api_discussion_presentation.pptx
+++ b/shiraku_notta_api_discussion_presentation.pptx
@@ -3250,7 +3250,8 @@
                 <a:latin typeface="Noto Sans"/>
               </a:rPr>
               <a:t>Archi-Record連携に向けた技術要件確認
-2026年3月</a:t>
+2026年3月
+※本資料はNotta API v0.4仕様書をベースに整合性確認済み</a:t>
             </a:r>
           </a:p>
         </p:txBody>
@@ -3309,7 +3310,7 @@
                 </a:solidFill>
                 <a:latin typeface="Noto Sans"/>
               </a:rPr>
-              <a:t>実現したい連携フロー</a:t>
+              <a:t>実現したい連携フロー（理想）</a:t>
             </a:r>
           </a:p>
         </p:txBody>
@@ -3385,7 +3386,7 @@
                 </a:solidFill>
                 <a:latin typeface="Noto Sans"/>
               </a:rPr>
-              <a:t>議事録動画 → Notta（AI処理）→ JSON自動送信 → Archi-Recordチェックリストに自動入力</a:t>
+              <a:t>議事録動画 → Notta（AI処理）→ Archi-Record自動入力。ただしSTEP1〜3はAPI v1の制約あり（後述）</a:t>
             </a:r>
           </a:p>
         </p:txBody>
@@ -3498,8 +3499,13 @@
               </a:rPr>
               <a:t>【Pattern A】Zoom MeetingにNotta Botを招待
 　→ Zoom参加者名を話者名に自動変換・高精度識別
+　⚠️ Bot派遣APIはv1後半〜v2で検討中（v1では未提供）
 【Pattern B】録画済み MP4/MP3 をアップロード
-　→ 話者1・話者2として識別（後で名前を編集）</a:t>
+　→ 話者1・話者2として識別（後で名前を編集）
+　⚠️ ファイルアップロードAPIもv1後半〜v2で検討中
+【v1で確実に使えるもの】
+　Nottaアプリ（Web/モバイル）で録音・アップロード済みのノートに
+　APIでアクセスしてデータ取得する形が v1 の現実的な経路</a:t>
             </a:r>
           </a:p>
         </p:txBody>
@@ -3577,7 +3583,7 @@
                 </a:solidFill>
                 <a:latin typeface="Noto Sans"/>
               </a:rPr>
-              <a:t>STEP 2｜Nottaで議事録を自動生成</a:t>
+              <a:t>STEP 2｜NottaのAPI出力データ</a:t>
             </a:r>
           </a:p>
         </p:txBody>
@@ -3610,10 +3616,14 @@
                 </a:solidFill>
                 <a:latin typeface="Noto Sans"/>
               </a:rPr>
-              <a:t>① 音声解析・文字起こし
-② 話者識別（スピーカー分離）
-③ 質疑応答をQ&amp;Aペアとして構造化
-④ タイムスタンプを各発言に付与</a:t>
+              <a:t>✅ 音声解析・文字起こし（セグメント単位）
+✅ 話者識別（speaker id/name）
+✅ タイムスタンプ（start/end を秒単位floatで付与）
+✅ AI要約（テキスト形式）
+⚠️ 「質疑応答をQ&amp;Aペアとして構造化」する機能は
+　 API v0.4仕様に記載なし → Notta内部で要確認
+⚠️ スクリーンショット取得・CDNアップロード機能も
+　 API v0.4仕様に記載なし → Notta内部で要確認</a:t>
             </a:r>
           </a:p>
         </p:txBody>
@@ -3691,7 +3701,7 @@
                 </a:solidFill>
                 <a:latin typeface="Noto Sans"/>
               </a:rPr>
-              <a:t>STEP 3｜JSON形式でArchi-Recordへ自動送信</a:t>
+              <a:t>STEP 3｜Archi-Recordへのデータ連携</a:t>
             </a:r>
           </a:p>
         </p:txBody>
@@ -3724,12 +3734,17 @@
                 </a:solidFill>
                 <a:latin typeface="Noto Sans"/>
               </a:rPr>
-              <a:t>1レコード＝Q&amp;Aペア1組
-　• 質問内容 / 質問者
-　• 回答 / 回答者
-　• スクリーンショット（候補3-5枚）
-　• タイムスタンプ
-議事録確定 → Webhook POSTで自動配信</a:t>
+              <a:t>【Webhookの役割】
+　文字起こし/要約の完了を通知（note_id + metadata を含む）
+　→ フルデータ（transcript全文）は含まれない
+【pull型フロー（API仕様に整合）】
+　① NottaがWebhook（transcript.completed）を送信
+　② Archi-RecordがWebhookを受信
+　③ Archi-RecordがNotta APIを呼び出し
+　   GET /v1/notes/{id}/transcript でデータ取得
+　④ Archi-Record側でデータを整形・登録
+→ 「NottaがArchi-Recordに全データをPOST」
+　 ではなく「Archi-RecordがNottaからpull取得」が現実的な設計</a:t>
             </a:r>
           </a:p>
         </p:txBody>
@@ -3807,7 +3822,7 @@
                 </a:solidFill>
                 <a:latin typeface="Noto Sans"/>
               </a:rPr>
-              <a:t>STEP 4｜チェックリストへ自動入力</a:t>
+              <a:t>STEP 4｜チェックリストへの自動入力</a:t>
             </a:r>
           </a:p>
         </p:txBody>
@@ -3841,11 +3856,13 @@
                 <a:latin typeface="Noto Sans"/>
               </a:rPr>
               <a:t>Archi-RecordのCheck Listに
-各Q&amp;Aペアが1行ずつ自動追加：
+各発言・Q&amp;Aが1行ずつ自動追加：
 　□ 質問内容 ／ 質問者
 　□ 回答内容 ／ 回答者
-　📷 スクリーンショット（添付）
-→ 手動転記ゼロ・ミス防止</a:t>
+※Q&amp;A構造化がNotta側で提供されない場合：
+　Archi-Record側でtranscriptセグメントを
+　LLM等で処理してQ&amp;Aペアに変換する実装が必要
+→ どちら側で処理するか方針確定が先決事項</a:t>
             </a:r>
           </a:p>
         </p:txBody>
@@ -3904,7 +3921,7 @@
                 </a:solidFill>
                 <a:latin typeface="Noto Sans"/>
               </a:rPr>
-              <a:t>送受信するJSONデータの仕様</a:t>
+              <a:t>Notta API v1 スコープ整理</a:t>
             </a:r>
           </a:p>
         </p:txBody>
@@ -3980,7 +3997,7 @@
                 </a:solidFill>
                 <a:latin typeface="Noto Sans"/>
               </a:rPr>
-              <a:t>1レコード＝Q&amp;Aペア1組。5フィールド＋タイムスタンプで構成。スクリーンショットは基本1枚</a:t>
+              <a:t>v1で確実に使えるものとv1後半〜v2検討中のものを明確に区別して開発計画を立てる</a:t>
             </a:r>
           </a:p>
         </p:txBody>
@@ -4058,7 +4075,7 @@
                 </a:solidFill>
                 <a:latin typeface="Noto Sans"/>
               </a:rPr>
-              <a:t>JSONフィールド構成（1レコード）</a:t>
+              <a:t>✅ v1で提供される機能</a:t>
             </a:r>
           </a:p>
         </p:txBody>
@@ -4091,14 +4108,14 @@
                 </a:solidFill>
                 <a:latin typeface="Noto Sans"/>
               </a:rPr>
-              <a:t>{
-  "question"     : "質問の内容テキスト",
-  "questioner"   : "質問者の名前",
-  "answer"       : "回答の内容テキスト",
-  "answerer"     : "回答者の名前",
-  "screenshots"  : ["url1", "url2", ...],
-  "timestamp"    : "00:12:34"
-}</a:t>
+              <a:t>• ノート一覧・詳細取得（フィルタ・ページネーション）
+• 文字起こし取得（セグメント：話者/タイムスタンプ/テキスト）
+• AI要約取得
+• メタデータ読み書き（外部システムIDとの紐づけ）
+• Webhook通知
+  - transcript.completed / transcript.failed
+  - summary.completed / summary.failed
+• APIキー認証（ワークスペース単位で発行）</a:t>
             </a:r>
           </a:p>
         </p:txBody>
@@ -4176,7 +4193,7 @@
                 </a:solidFill>
                 <a:latin typeface="Noto Sans"/>
               </a:rPr>
-              <a:t>スクリーンショットの取得方針</a:t>
+              <a:t>⚠️ v1後半〜v2で検討中（現時点で未提供）</a:t>
             </a:r>
           </a:p>
         </p:txBody>
@@ -4209,12 +4226,16 @@
                 </a:solidFill>
                 <a:latin typeface="Noto Sans"/>
               </a:rPr>
-              <a:t>【取得タイミング】
-　質問者の発話開始タイムスタンプ起点
-　→ 10秒ごとに1枚ずつキャプチャ
-【枚数】基本1枚でOK（3-5枚候補から選択）
-【動画ファイル】処理後は保存不要
-　→ ストレージ節約・プライバシー配慮</a:t>
+              <a:t>• Bot派遣API（Zoom等への自動参加）
+• ファイルアップロードAPI（MP4/MP3等）
+• 音声ファイルダウンロード
+• ワークスペース管理（メンバー追加/削除）
+• APIキーのアクセス範囲細分化
+  （ユーザー/グループ/フォルダ単位）
+⚠️ v0.4で未確定の事項
+• プライベートノートへのアクセス権限モデル
+• Q&amp;A構造化エンジン
+• スクリーンショット取得・CDN機能</a:t>
             </a:r>
           </a:p>
         </p:txBody>
@@ -4292,7 +4313,7 @@
                 </a:solidFill>
                 <a:latin typeface="Noto Sans"/>
               </a:rPr>
-              <a:t>Pattern A vs B　話者識別精度比較</a:t>
+              <a:t>PoCで現実的に使えるv1の経路</a:t>
             </a:r>
           </a:p>
         </p:txBody>
@@ -4325,13 +4346,13 @@
                 </a:solidFill>
                 <a:latin typeface="Noto Sans"/>
               </a:rPr>
-              <a:t>【Pattern A】Notta Bot（Zoom参加）
-　◎ Zoom表示名 → 話者名を自動変換
-　◎ 高精度な話者識別
-　→ 推奨シナリオ
-【Pattern B】MP4/MP3 アップロード
-　△ 「話者1・話者2」で識別
-　→ 名前の後付け編集が必要</a:t>
+              <a:t>Nottaアプリで録音済み（またはアップロード済み）のノートに対して：
+① Webアプリ / モバイルで録音・ファイルアップロード
+② 文字起こし・要約が完了したらWebhookで通知
+③ Archi-RecordがNotta APIでtranscriptをpull取得
+④ Archi-Record側でデータ整形 → チェックリスト自動入力
+→ STEP1の自動化（Botやファイルアップロードの完全自動化）は
+　 v2以降。PoCではNotta手動操作 + API取得の構成が現実的</a:t>
             </a:r>
           </a:p>
         </p:txBody>
@@ -4409,7 +4430,7 @@
                 </a:solidFill>
                 <a:latin typeface="Noto Sans"/>
               </a:rPr>
-              <a:t>NottaのUIでの連携イメージ</a:t>
+              <a:t>メタデータによるノート↔プロジェクトの紐づけ</a:t>
             </a:r>
           </a:p>
         </p:txBody>
@@ -4442,12 +4463,17 @@
                 </a:solidFill>
                 <a:latin typeface="Noto Sans"/>
               </a:rPr>
-              <a:t>「連携とアプリ」→「すべての連携サービス」
-　→ Archi-Recordが一覧に追加される
-　（Slack・Salesforceと同列のUI）
-オートメーション設定で：
-　アクション → 「Archi-Recordに送信」
-　オプション → 「プロジェクトを選択」</a:t>
+              <a:t>API仕様の中核機能：メタデータ（key-value）
+【仕組み】
+　Nottaのノートに archi_record_project_id を付与：
+　PATCH /v1/notes/{id}/metadata
+　{ "archi_record_project_id": "proj-xxx" }
+【効果】
+　Webhookペイロードにmetadataが含まれるため
+　Archi-Recordは受信時点で「どのプロジェクトに
+　紐づけるか」を即座に特定できる
+→ UIでプロジェクト選択 → Notta側にmetadataを書き込む
+　 という設計がAPI仕様に最も整合する</a:t>
             </a:r>
           </a:p>
         </p:txBody>
@@ -4506,7 +4532,7 @@
                 </a:solidFill>
                 <a:latin typeface="Noto Sans"/>
               </a:rPr>
-              <a:t>Notta API開発で考慮すべき4テーマ</a:t>
+              <a:t>Nottaが取得できるデータ仕様（v1実態）</a:t>
             </a:r>
           </a:p>
         </p:txBody>
@@ -4582,7 +4608,7 @@
                 </a:solidFill>
                 <a:latin typeface="Noto Sans"/>
               </a:rPr>
-              <a:t>「OAuth設計」「Q&amp;A抽出」「スクリーンショット取得」「Webhook配信」がNotta側の主要開発項目</a:t>
+              <a:t>NottaはQ&amp;A構造化済みJSONではなく生セグメントデータを返す。Q&amp;A変換はArchi-Record側 or Notta追加実装で対応</a:t>
             </a:r>
           </a:p>
         </p:txBody>
@@ -4660,7 +4686,7 @@
                 </a:solidFill>
                 <a:latin typeface="Noto Sans"/>
               </a:rPr>
-              <a:t>① OAuth認証フロー設計</a:t>
+              <a:t>Notta APIが実際に返すデータ（transcript）</a:t>
             </a:r>
           </a:p>
         </p:txBody>
@@ -4693,13 +4719,22 @@
                 </a:solidFill>
                 <a:latin typeface="Noto Sans"/>
               </a:rPr>
-              <a:t>Archi-RecordはGoogle SSO採用
-→ Slack型OAuthとの差分設計が必要
-検討アプローチ：
-　A) Archi-RecordがNotta向けに
-　   OAuth 2.0クライアントを発行
-　B) Google IDトークンを転送して連携
-※どちらが実現可能かをSHIRAKUと確認</a:t>
+              <a:t>GET /v1/notes/{id}/transcript のレスポンス：
+{
+  "note_id": "550e8400-...",
+  "language": "ja",
+  "segments": [
+    {
+      "id": "seg-001",
+      "speaker": { "id": "spk-001", "name": "田中太郎" },
+      "start": 0.0,
+      "end": 5.2,
+      "text": "それでは本日のミーティングを始めます。"
+    }
+  ],
+  "has_more": true,
+  "next_cursor": "..."
+}</a:t>
             </a:r>
           </a:p>
         </p:txBody>
@@ -4777,7 +4812,7 @@
                 </a:solidFill>
                 <a:latin typeface="Noto Sans"/>
               </a:rPr>
-              <a:t>② Q&amp;A構造化エンジン</a:t>
+              <a:t>理想のJSON（Q&amp;Aペア）との差分</a:t>
             </a:r>
           </a:p>
         </p:txBody>
@@ -4810,12 +4845,19 @@
                 </a:solidFill>
                 <a:latin typeface="Noto Sans"/>
               </a:rPr>
-              <a:t>発話テキストから「質問」「回答」を自動抽出
-【LLMアプローチ】高精度・コスト高
-　→ 文脈を理解して判定
-【ルールベース】高速・低コスト
-　→ 疑問符・助詞・話者交替で判定
-建築専門用語への対応も検討が必要</a:t>
+              <a:t>【理想（PPT v1時点の記載）】
+{
+  "question"   : "○○の仕様はどうなりますか？",
+  "questioner" : "田中太郎",
+  "answer"     : "○○については△△の方針で...",
+  "answerer"   : "鈴木一郎",
+  "screenshots": ["https://cdn.notta.ai/..."],
+  "timestamp"  : "00:12:34"
+}
+⚠️ 差分：
+  • Q/A構造化 → Notta API v1に存在しない
+  • screenshots → Notta API v1に存在しない
+  • 上記2点はいずれかの側での追加実装が必要</a:t>
             </a:r>
           </a:p>
         </p:txBody>
@@ -4893,7 +4935,7 @@
                 </a:solidFill>
                 <a:latin typeface="Noto Sans"/>
               </a:rPr>
-              <a:t>③ スクリーンショット取得</a:t>
+              <a:t>Webhookペイロード（実際の仕様）</a:t>
             </a:r>
           </a:p>
         </p:txBody>
@@ -4926,13 +4968,23 @@
                 </a:solidFill>
                 <a:latin typeface="Noto Sans"/>
               </a:rPr>
-              <a:t>【取得フロー】
-　① Zoom録画 or MP4ファイル取得
-　② タイムスタンプ指定でフレーム抽出
-　   （ffmpeg等で処理）
-　③ Notta CDNにアップロード → URL生成
-　④ 動画ファイルを処理後に削除
-映り込みの法的対応も確認が必要</a:t>
+              <a:t>transcript.completed 時のWebhookペイロード：
+{
+  "event": "transcript.completed",
+  "timestamp": "2026-03-17T10:05:00Z",
+  "delivery_id": "dlv_7f3a1b2c...",
+  "data": {
+    "note_id": "550e8400-...",
+    "title": "〇〇社 現場確認会議",
+    "source": "zoom",
+    "duration": 1800,
+    "metadata": {
+      "archi_record_project_id": "proj-xxx"
+    }
+  }
+}
+→ フルtranscriptは含まれない（通知のみ）
+　 Archi-Record側で別途APIコールが必要</a:t>
             </a:r>
           </a:p>
         </p:txBody>
@@ -5010,7 +5062,7 @@
                 </a:solidFill>
                 <a:latin typeface="Noto Sans"/>
               </a:rPr>
-              <a:t>④ Webhook / JSON配信設計</a:t>
+              <a:t>Webhook仕様（正確な値）</a:t>
             </a:r>
           </a:p>
         </p:txBody>
@@ -5043,13 +5095,16 @@
                 </a:solidFill>
                 <a:latin typeface="Noto Sans"/>
               </a:rPr>
-              <a:t>【送信タイミング】議事録確定時に自動POST
-設計上の考慮点：
-　• 冪等性（二重送信防止）
-　• リトライ（最大3回・指数バックオフ）
-　• 送信ログの保持
-スクリーンショットの送信形式：
-　URLリンク or Base64？→ SHIRAKU確認要</a:t>
+              <a:t>【署名】HMAC-SHA256（X-Notta-Signatureヘッダー）
+【重複排除】X-Notta-Delivery-Id で冪等性担保
+【リプレイ対策】X-Notta-Timestamp（5分以内のみ受理）
+【リトライポリシー（API仕様の正確な値）】
+　1回目：5分後
+　2回目：30分後
+　3回目：2時間後
+　4回目（最終）：24時間後
+　タイムアウト：10秒
+※PPT旧版の「最大3回・指数バックオフ」は誤り → 上記に修正</a:t>
             </a:r>
           </a:p>
         </p:txBody>
@@ -5184,7 +5239,7 @@
                 </a:solidFill>
                 <a:latin typeface="Noto Sans"/>
               </a:rPr>
-              <a:t>API仕様・OAuth・スクリーンショット技術仕様・話者マッピングの4点を先に確定することが開発着手の前提</a:t>
+              <a:t>アーキテクチャ方針・受信API仕様・スクリーンショット・話者マッピングの4点が開発着手の前提確認事項</a:t>
             </a:r>
           </a:p>
         </p:txBody>
@@ -5262,7 +5317,7 @@
                 </a:solidFill>
                 <a:latin typeface="Noto Sans"/>
               </a:rPr>
-              <a:t>確認① Archi-Record受信API仕様</a:t>
+              <a:t>確認① 連携アーキテクチャの方針</a:t>
             </a:r>
           </a:p>
         </p:txBody>
@@ -5295,12 +5350,15 @@
                 </a:solidFill>
                 <a:latin typeface="Noto Sans"/>
               </a:rPr>
-              <a:t>• REST API（POST）かWebhookか？
-• エンドポイントURL・認証方式は？
-   （Bearer Token / HMAC署名 / APIキー）
-• レスポンスコード定義（200/400/409等）
-• OpenAPI仕様書・Postmanコレクション
-  があれば共有をお願いしたい</a:t>
+              <a:t>【pull型】Archi-RecordがNotta APIを呼び出してデータ取得
+　→ API仕様に整合。Archi-Record側に実装コスト
+【push型】NottaがArchi-RecordのエンドポイントにPOST
+　→ API仕様に定義なし（追加実装が必要）
+→ どちらのアーキテクチャで進めるか確認したい
+　※pull型の場合：ArchiRecord側でNotta APIキーを保持し
+　  GET /v1/notes/{id}/transcript を呼び出す実装が必要
+関連：メタデータ（archi_record_project_id）による
+ノート↔プロジェクト紐づけ方式に合意いただけるか？</a:t>
             </a:r>
           </a:p>
         </p:txBody>
@@ -5378,7 +5436,7 @@
                 </a:solidFill>
                 <a:latin typeface="Noto Sans"/>
               </a:rPr>
-              <a:t>確認② OAuth認証方式の詳細</a:t>
+              <a:t>確認② Archi-Record受信API仕様（push型の場合）</a:t>
             </a:r>
           </a:p>
         </p:txBody>
@@ -5411,13 +5469,13 @@
                 </a:solidFill>
                 <a:latin typeface="Noto Sans"/>
               </a:rPr>
-              <a:t>• Notta向けにOAuth 2.0クライアントID
-  を発行できるか？
-• 既存Slack連携のOAuthフロー・
-  シーケンス図を共有いただけるか？
-• Google IDトークン転送方式は
-  採用可能か？
-→ 認証設計の最重要確認事項</a:t>
+              <a:t>• REST API（POST）かWebhookか？
+• エンドポイントURL・認証方式は？
+   （Bearer Token / HMAC署名 / APIキー）
+• レスポンスコード定義（200/400/409等）
+• OpenAPI仕様書・Postmanコレクション
+  があれば共有をお願いしたい
+※pull型を採用する場合は確認不要</a:t>
             </a:r>
           </a:p>
         </p:txBody>
@@ -5495,7 +5553,7 @@
                 </a:solidFill>
                 <a:latin typeface="Noto Sans"/>
               </a:rPr>
-              <a:t>確認③ スクリーンショット技術仕様</a:t>
+              <a:t>確認③ スクリーンショット機能の要件</a:t>
             </a:r>
           </a:p>
         </p:txBody>
@@ -5528,13 +5586,17 @@
                 </a:solidFill>
                 <a:latin typeface="Noto Sans"/>
               </a:rPr>
-              <a:t>• Attach機能の対応フォーマット？
-  （JPEG / PNG / WebP）
-• 1ファイルあたりサイズ上限は？
-• 最終的に何枚送信すればよい？
-  （現資料：基本1枚 / 候補3-5枚）
-• Notta側で枚数選択UIを提供するか
-  Archi-Record側で自動選択するか？</a:t>
+              <a:t>現状：Notta API v1にスクリーンショット機能は存在しない
+→ SHIRAKUへの確認事項：
+• スクリーンショットは必須要件か？（PoC時点でも必要か）
+• 必須の場合、どちら側で実装するか検討したい
+   A) Notta側に追加実装を要望（v2以降の検討項目）
+   B) Archi-Record側でZoom録画から独自にフレーム抽出
+   C) スクリーンショットなしでPoC開始し、後工程で追加
+• 仮に提供できる場合の技術仕様：
+   対応フォーマット（JPEG/PNG/WebP）
+   1ファイルあたりサイズ上限
+   1会議あたりの想定枚数</a:t>
             </a:r>
           </a:p>
         </p:txBody>
@@ -5651,7 +5713,9 @@
 　メンバーリスト取得APIはあるか？
 Pattern B（MP4/MP3）の場合：
 　「話者1・話者2」→ 名前編集後に
-　Archi-Recordへ反映するフローは？</a:t>
+　Archi-Recordへ反映するフローは？
+補足：Pattern A・Bどちらも v1後半〜v2予定。
+→ PoCスコープと合わせて優先度を確認したい</a:t>
             </a:r>
           </a:p>
         </p:txBody>
@@ -5786,7 +5850,7 @@
                 </a:solidFill>
                 <a:latin typeface="Noto Sans"/>
               </a:rPr>
-              <a:t>PoCスコープと成功KPIの早期合意で、両社の開発リソースを適切に配置する</a:t>
+              <a:t>v1制約を踏まえた現実的なPoCスコープの合意が最優先。Bot/UploadAPIなしでの検証設計が必要</a:t>
             </a:r>
           </a:p>
         </p:txBody>
@@ -5864,7 +5928,7 @@
                 </a:solidFill>
                 <a:latin typeface="Noto Sans"/>
               </a:rPr>
-              <a:t>確認⑤ PoCスコープ</a:t>
+              <a:t>確認⑤ PoCスコープ（v1制約を踏まえて）</a:t>
             </a:r>
           </a:p>
         </p:txBody>
@@ -5897,13 +5961,17 @@
                 </a:solidFill>
                 <a:latin typeface="Noto Sans"/>
               </a:rPr>
-              <a:t>• 対象会議の種類・件数・参加者数上限
-• Pattern A / B どちらを先行検証？
-• テスト対象のチェックリスト
-  テンプレート種類は？
-• 1会議あたりのQ&amp;Aペア平均件数は？
-• PoC開始に向けたサンドボックス環境は
-  提供可能か？</a:t>
+              <a:t>v1の現実的な構成：
+　Nottaアプリで録音/アップロード（手動）
+　→ API経由でtranscript取得 → 自動入力
+確認したい点：
+• 上記構成でもPoCとして成立するか？
+• 対象会議の種類・件数・参加者数上限
+• テスト対象のチェックリストテンプレート種類
+• 1会議あたりのQ&amp;Aペア平均件数の想定
+• PoC開始に向けたサンドボックス環境の提供は可能か？
+• Bot派遣やFile Upload APIが揃う前に
+  PoCを開始する場合のリスク許容度は？</a:t>
             </a:r>
           </a:p>
         </p:txBody>
@@ -6020,7 +6088,10 @@
    A) ユーザーが手動修正
    B) Nottaへ再送信を要求
 • 人間承認ステップは必要か？
-   → 確認後自動反映 / 即時反映？</a:t>
+   → 確認後自動反映 / 即時反映？
+• Q&amp;A構造化をNottaが提供しない場合、
+  Archi-Record側のLLM処理コスト・精度は
+  受け入れ可能か？</a:t>
             </a:r>
           </a:p>
         </p:txBody>
@@ -6131,12 +6202,17 @@
                 </a:solidFill>
                 <a:latin typeface="Noto Sans"/>
               </a:rPr>
-              <a:t>【M1】API仕様・JSONスキーマ合意
-【M2】OAuth認証フロー実装完了
-【M3】Q&amp;A構造化 + スクショ取得完了
-【M4】結合テスト・E2E検証
-【M5】PoC本番開始・評価
-→ 各マイルストーンの目標日を確定したい</a:t>
+              <a:t>【M1】アーキテクチャ方針・JSONスキーマ合意
+　　　（Q&amp;A構造化 / スクリーンショットの担当整理含む）
+【M2】認証・メタデータ紐づけ実装完了
+　　　（APIキー発行 + archi_record_project_id連携）
+【M3】Webhook受信 + transcript pull取得 完了
+【M4】Q&amp;A変換 + チェックリスト自動入力 完了
+【M5】結合テスト・E2E検証
+【M6】PoC本番開始・評価
+→ 各マイルストーンの目標日を確定したい
+　※BotAPI/FileUploadAPIの提供時期が確定次第
+　 M1〜M3を見直す可能性あり</a:t>
             </a:r>
           </a:p>
         </p:txBody>
@@ -6251,7 +6327,8 @@
 • 仕様変更の受付フロー
   （Notion / GitHub / メール等）
 • データ利用・NDA・DPA締結の要否
-  ※映像・発言者情報の個人情報扱い
+  ※transcriptデータ（発言録）・参加者情報は
+  　個人情報に該当する可能性があり確認が必要
 • 定期MTGの頻度・初回キックオフ日程</a:t>
             </a:r>
           </a:p>

</xml_diff>